<commit_message>
Make the heist presentation standalone
Remove the source-video framing and comparison content: drop the
fact-check scoreboard slide, rewrite narrative text and speaker notes
to stand on the analysis alone, and scrub references from the analysis
scripts, fact base, and README. Deck is now 12 slides.

Co-Authored-By: Claude Fable 5 <noreply@anthropic.com>
Claude-Session: https://claude.ai/code/session_01MngMbwTTWJ2bTRMHfRN4M1
</commit_message>
<xml_diff>
--- a/presentations/lebron-heist/lebron-sixers-heist.pptx
+++ b/presentations/lebron-heist/lebron-sixers-heist.pptx
@@ -17,10 +17,9 @@
     <p:sldId id="265" r:id="rId11"/>
     <p:sldId id="266" r:id="rId12"/>
     <p:sldId id="267" r:id="rId13"/>
-    <p:sldId id="268" r:id="rId14"/>
   </p:sldIdLst>
   <p:notesMasterIdLst>
-    <p:notesMasterId r:id="rId15"/>
+    <p:notesMasterId r:id="rId14"/>
   </p:notesMasterIdLst>
   <p:sldSz cx="12192000" cy="6858000"/>
   <p:notesSz cx="6858000" cy="12192000"/>
@@ -3716,7 +3715,7 @@
           <a:p>
             <a:r>
               <a:rPr lang="en-US" dirty="0"/>
-              <a:t>Recreates the opening thesis of the video: LeBron going to the 76ers is the biggest heist in NBA free agency history — the one player who has organized top-5 offenses as a solo hub for two decades signed for $8M over two years with the exact team whose fatal flaw is the thing he fixes.</a:t>
+              <a:t>The thesis: LeBron going to the 76ers is the biggest heist in NBA free agency history — the player who has organized top-5 offenses as a solo hub for two decades signed for $8M over two years with the exact team whose fatal flaw is the thing he fixes.</a:t>
             </a:r>
             <a:endParaRPr lang="en-US" dirty="0"/>
           </a:p>
@@ -3804,7 +3803,7 @@
           <a:p>
             <a:r>
               <a:rPr lang="en-US" dirty="0"/>
-              <a:t>Her chart: usage 27.2→22, TS .594→.627 ('63%' bar). Mine: 21.5% usage central, TS .615 central with .60-.63 range — her TS sits at my optimistic bound. Her mixing of a 63% bar next to usage percentages is also why my version separates the two scales into two charts.</a:t>
+              <a:t>The paradox of the signing: giving LeBron less to do makes him better. Usage projects to ~21-22% (the Bosh/Love arrival sheds applied to him), and the efficiency tradeoff projects TS toward .61-.63 at age 42.</a:t>
             </a:r>
             <a:endParaRPr lang="en-US" dirty="0"/>
           </a:p>
@@ -3980,7 +3979,7 @@
           <a:p>
             <a:r>
               <a:rPr lang="en-US" dirty="0"/>
-              <a:t>The honest scoreboard: most of her data was excellent (Maxey/Brown/LeBron numbers verify to the decimal); the Edgecombe chart and the LeBron assist-count are the two real errors; her curve had the right shape with a soft baseline.</a:t>
+              <a:t>Method summary and provenance. All scripts and the source data file (data.md) accompany the deck in the repository.</a:t>
             </a:r>
             <a:endParaRPr lang="en-US" dirty="0"/>
           </a:p>
@@ -4004,94 +4003,6 @@
             <a:fld id="{F7021451-1387-4CA6-816F-3879F97B5CBC}" type="slidenum">
               <a:rPr lang="en-US"/>
               <a:t>12</a:t>
-            </a:fld>
-            <a:endParaRPr lang="en-US"/>
-          </a:p>
-        </p:txBody>
-      </p:sp>
-    </p:spTree>
-    <p:extLst>
-      <p:ext uri="{BB962C8B-B14F-4D97-AF65-F5344CB8AC3E}">
-        <p14:creationId xmlns:p14="http://schemas.microsoft.com/office/powerpoint/2010/main" val="1024086991"/>
-      </p:ext>
-    </p:extLst>
-  </p:cSld>
-  <p:clrMapOvr>
-    <a:masterClrMapping/>
-  </p:clrMapOvr>
-</p:notes>
-</file>
-
-<file path=ppt/notesSlides/notesSlide13.xml><?xml version="1.0" encoding="utf-8"?>
-<p:notes xmlns:a="http://schemas.openxmlformats.org/drawingml/2006/main" xmlns:r="http://schemas.openxmlformats.org/officeDocument/2006/relationships" xmlns:p="http://schemas.openxmlformats.org/presentationml/2006/main">
-  <p:cSld>
-    <p:spTree>
-      <p:nvGrpSpPr>
-        <p:cNvPr id="1" name=""/>
-        <p:cNvGrpSpPr/>
-        <p:nvPr/>
-      </p:nvGrpSpPr>
-      <p:grpSpPr>
-        <a:xfrm>
-          <a:off x="0" y="0"/>
-          <a:ext cx="0" cy="0"/>
-          <a:chOff x="0" y="0"/>
-          <a:chExt cx="0" cy="0"/>
-        </a:xfrm>
-      </p:grpSpPr>
-      <p:sp>
-        <p:nvSpPr>
-          <p:cNvPr id="2" name="Slide Image Placeholder 1"/>
-          <p:cNvSpPr>
-            <a:spLocks noGrp="1" noRot="1" noChangeAspect="1"/>
-          </p:cNvSpPr>
-          <p:nvPr>
-            <p:ph type="sldImg"/>
-          </p:nvPr>
-        </p:nvSpPr>
-        <p:spPr/>
-      </p:sp>
-      <p:sp>
-        <p:nvSpPr>
-          <p:cNvPr id="3" name="Notes Placeholder 2"/>
-          <p:cNvSpPr>
-            <a:spLocks noGrp="1"/>
-          </p:cNvSpPr>
-          <p:nvPr>
-            <p:ph type="body" idx="1"/>
-          </p:nvPr>
-        </p:nvSpPr>
-        <p:spPr/>
-        <p:txBody>
-          <a:bodyPr/>
-          <a:lstStyle/>
-          <a:p>
-            <a:r>
-              <a:rPr lang="en-US" dirty="0"/>
-              <a:t>Method summary and provenance. All scripts and the source data file (data.md) accompany the deck in the repository.</a:t>
-            </a:r>
-            <a:endParaRPr lang="en-US" dirty="0"/>
-          </a:p>
-        </p:txBody>
-      </p:sp>
-      <p:sp>
-        <p:nvSpPr>
-          <p:cNvPr id="4" name="Slide Number Placeholder 3"/>
-          <p:cNvSpPr>
-            <a:spLocks noGrp="1"/>
-          </p:cNvSpPr>
-          <p:nvPr>
-            <p:ph type="sldNum" sz="quarter" idx="10"/>
-          </p:nvPr>
-        </p:nvSpPr>
-        <p:spPr/>
-        <p:txBody>
-          <a:bodyPr/>
-          <a:lstStyle/>
-          <a:p>
-            <a:fld id="{F7021451-1387-4CA6-816F-3879F97B5CBC}" type="slidenum">
-              <a:rPr lang="en-US"/>
-              <a:t>13</a:t>
             </a:fld>
             <a:endParaRPr lang="en-US"/>
           </a:p>
@@ -4156,7 +4067,7 @@
           <a:p>
             <a:r>
               <a:rPr lang="en-US" dirty="0"/>
-              <a:t>Her setup: 'a player with arguably the greatest playoff IQ alive just signed for only $8 million on a two-year contract.' Verified: $3.876M year one with a year-two player option; he made $52.6M in 2025-26.</a:t>
+              <a:t>The deal itself: $3.876M year one with a year-two player option — the 10+ year veteran minimum. He made $52.6M with the Lakers in 2025-26; this is the largest pay cut in NBA history.</a:t>
             </a:r>
             <a:endParaRPr lang="en-US" dirty="0"/>
           </a:p>
@@ -4244,7 +4155,7 @@
           <a:p>
             <a:r>
               <a:rPr lang="en-US" dirty="0"/>
-              <a:t>Her thesis restated with verified numbers: 'the one player who has organized top-5 offenses as the solo hub over the last two decades… to the exact team whose one fatal flaw is the exact thing that he fixes.'</a:t>
+              <a:t>The matchup logic: the Sixers' one structural weakness — shot creation for everyone but Maxey — is precisely LeBron's elite skill. Every red number on the right is a symptom of the same missing pass.</a:t>
             </a:r>
             <a:endParaRPr lang="en-US" dirty="0"/>
           </a:p>
@@ -4332,7 +4243,7 @@
           <a:p>
             <a:r>
               <a:rPr lang="en-US" dirty="0"/>
-              <a:t>Her claim: 'The new Sixers are projected to have 51 wins.' Rebuilt independently: SRS-true 41 + 5 (LeBron) + 3 (Brown full season) + 2 (Embiid health) = 51, and the sportsbook total (50.5) matches.</a:t>
+              <a:t>The win projection: SRS-true 41 + 5 (LeBron) + 3 (Brown full season) + 2 (Embiid health) = 51, and the sportsbook total (50.5) lands in the same place.</a:t>
             </a:r>
             <a:endParaRPr lang="en-US" dirty="0"/>
           </a:p>
@@ -4420,7 +4331,7 @@
           <a:p>
             <a:r>
               <a:rPr lang="en-US" dirty="0"/>
-              <a:t>Her chart: 'FINALS PROBABILITY vs WINS — Log5 model, three playoff rounds', 45→4%, 51→12%, 3.2x. Mine, built from scratch, is steeper: 2.1%→8.1% (3.8x), and the 2.6% empirical rate for 44-47-win teams says the lower baseline is the right one.</a:t>
+              <a:t>Why 51 wins matters so much more than 45: Finals probability is not linear in wins. The Log5 model gives 2.1% at 45 wins and 8.1% at 51 — a 3.8x jump — and the empirical rate for 44-47-win teams (2.6% of berths since 1984) confirms the low starting point.</a:t>
             </a:r>
             <a:endParaRPr lang="en-US" dirty="0"/>
           </a:p>
@@ -4508,7 +4419,7 @@
           <a:p>
             <a:r>
               <a:rPr lang="en-US" dirty="0"/>
-              <a:t>Her chart: 55 / 36 / 45 with n=694 — her baseline and league numbers verify exactly. My projection (46.9%) uses the verified guard-arrival deltas.</a:t>
+              <a:t>Maxey has been the league's most self-reliant high-volume scorer: 55.3% of his makes unassisted vs a 36.3% league mean. The guard-arrival comps project that down to ~47% — easier shots at the same volume.</a:t>
             </a:r>
             <a:endParaRPr lang="en-US" dirty="0"/>
           </a:p>
@@ -4596,7 +4507,7 @@
           <a:p>
             <a:r>
               <a:rPr lang="en-US" dirty="0"/>
-              <a:t>Her chart: 36 / 46 / 48. Verified: 36.4 / 47.6; my projection is slightly higher than hers (51.6 vs 48) because the arrival premium is real and positive.</a:t>
+              <a:t>Brown's assisted share collapsed to 36.4% carrying Boston at a career-high 36.2% usage. Restoring his healthy-co-star baseline (47.6%) plus half the measured LeBron-arrival premium projects ~52% — the easiest shot diet of his career.</a:t>
             </a:r>
             <a:endParaRPr lang="en-US" dirty="0"/>
           </a:p>
@@ -4684,7 +4595,7 @@
           <a:p>
             <a:r>
               <a:rPr lang="en-US" dirty="0"/>
-              <a:t>Her chart: 37 / 52 / 42. The 52%-of-765-assists claim doesn't reproduce; actual 2025-26 profile is 42.1% of 432. My projection still lands almost exactly on hers: 41.2%.</a:t>
+              <a:t>Embiid's 34.9% rim share is remarkably low for an MVP-level center — a symptom of entry passing, not finishing. LeBron's rim-heavy assist profile projects it to ~41%.</a:t>
             </a:r>
             <a:endParaRPr lang="en-US" dirty="0"/>
           </a:p>
@@ -4772,7 +4683,7 @@
           <a:p>
             <a:r>
               <a:rPr lang="en-US" dirty="0"/>
-              <a:t>Her chart: 8 / 10 / 12. Neither the baseline nor the projection survives the play-by-play data; mine: 5.5 / 11.8 / 6.9. Direction right, size overstated.</a:t>
+              <a:t>Edgecombe already hits assisted threes (81% of his 3P makes were assisted) — he just never got corner looks. LeBron's record-setting skip pass projects a ~30% relative jump in the best shot in basketball.</a:t>
             </a:r>
             <a:endParaRPr lang="en-US" dirty="0"/>
           </a:p>
@@ -5279,7 +5190,7 @@
                 <a:ea typeface="Calibri" pitchFamily="34" charset="-122"/>
                 <a:cs typeface="Calibri" pitchFamily="34" charset="-120"/>
               </a:rPr>
-              <a:t>What LeBron James to the 76ers actually means — rebuilt from source data, every number re-derived.</a:t>
+              <a:t>What LeBron James to the 76ers actually means — every number derived from source data.</a:t>
             </a:r>
             <a:endParaRPr lang="en-US" sz="1700" dirty="0"/>
           </a:p>
@@ -5318,21 +5229,7 @@
                 <a:ea typeface="Calibri" pitchFamily="34" charset="-122"/>
                 <a:cs typeface="Calibri" pitchFamily="34" charset="-120"/>
               </a:rPr>
-              <a:t>A data-verified recreation of the viral breakdown by TikTok’s @leah.cammarano. </a:t>
-            </a:r>
-            <a:pPr indent="0" marL="0">
-              <a:buNone/>
-            </a:pPr>
-            <a:r>
-              <a:rPr lang="en-US" sz="1150" i="1" dirty="0">
-                <a:solidFill>
-                  <a:srgbClr val="7E93AC"/>
-                </a:solidFill>
-                <a:latin typeface="Calibri" pitchFamily="34" charset="0"/>
-                <a:ea typeface="Calibri" pitchFamily="34" charset="-122"/>
-                <a:cs typeface="Calibri" pitchFamily="34" charset="-120"/>
-              </a:rPr>
-              <a:t>Her structure and thesis; independent stats, models, and projections throughout.</a:t>
+              <a:t>Verified play-by-play stats, a from-scratch playoff-probability model, and measured history of what happens to teammates when LeBron arrives.</a:t>
             </a:r>
             <a:endParaRPr lang="en-US" sz="1150" dirty="0"/>
           </a:p>
@@ -5600,7 +5497,7 @@
                 <a:ea typeface="Calibri" pitchFamily="34" charset="-122"/>
                 <a:cs typeface="Calibri" pitchFamily="34" charset="-120"/>
               </a:rPr>
-              <a:t>the skill-curve tradeoff (+0.3-0.6 TS pts per usage point shed, minus an age-42 drag) projects .594 → .60-.63. The video’s .627 is the optimistic edge of that band; his career best is .649 (2013-14).
+              <a:t>the skill-curve tradeoff (+0.3-0.6 TS pts per usage point shed, minus an age-42 drag) projects .594 → .60-.63 — brushing career-best territory (.649 in 2013-14) at the top of the band.
 </a:t>
             </a:r>
             <a:pPr indent="0" marL="0">
@@ -6186,3781 +6083,6 @@
 <file path=ppt/slides/slide12.xml><?xml version="1.0" encoding="utf-8"?>
 <p:sld xmlns:a="http://schemas.openxmlformats.org/drawingml/2006/main" xmlns:r="http://schemas.openxmlformats.org/officeDocument/2006/relationships" xmlns:p="http://schemas.openxmlformats.org/presentationml/2006/main">
   <p:cSld name="Slide 12">
-    <p:spTree>
-      <p:nvGrpSpPr>
-        <p:cNvPr id="1" name=""/>
-        <p:cNvGrpSpPr/>
-        <p:nvPr/>
-      </p:nvGrpSpPr>
-      <p:grpSpPr>
-        <a:xfrm>
-          <a:off x="0" y="0"/>
-          <a:ext cx="0" cy="0"/>
-          <a:chOff x="0" y="0"/>
-          <a:chExt cx="0" cy="0"/>
-        </a:xfrm>
-      </p:grpSpPr>
-      <p:sp>
-        <p:nvSpPr>
-          <p:cNvPr id="2" name="Text 0"/>
-          <p:cNvSpPr/>
-          <p:nvPr/>
-        </p:nvSpPr>
-        <p:spPr>
-          <a:xfrm>
-            <a:off x="548640" y="384048"/>
-            <a:ext cx="11091672" cy="274320"/>
-          </a:xfrm>
-          <a:prstGeom prst="rect">
-            <a:avLst/>
-          </a:prstGeom>
-          <a:noFill/>
-          <a:ln/>
-        </p:spPr>
-        <p:txBody>
-          <a:bodyPr wrap="square" lIns="0" tIns="0" rIns="0" bIns="0" rtlCol="0" anchor="ctr"/>
-          <a:lstStyle/>
-          <a:p>
-            <a:pPr indent="0" marL="0">
-              <a:buNone/>
-            </a:pPr>
-            <a:r>
-              <a:rPr lang="en-US" sz="1200" b="1" spc="200" kern="0" dirty="0">
-                <a:solidFill>
-                  <a:srgbClr val="C8102E"/>
-                </a:solidFill>
-                <a:latin typeface="Calibri" pitchFamily="34" charset="0"/>
-                <a:ea typeface="Calibri" pitchFamily="34" charset="-122"/>
-                <a:cs typeface="Calibri" pitchFamily="34" charset="-120"/>
-              </a:rPr>
-              <a:t>FACT-CHECK SCOREBOARD</a:t>
-            </a:r>
-            <a:endParaRPr lang="en-US" sz="1200" dirty="0"/>
-          </a:p>
-        </p:txBody>
-      </p:sp>
-      <p:sp>
-        <p:nvSpPr>
-          <p:cNvPr id="3" name="Text 1"/>
-          <p:cNvSpPr/>
-          <p:nvPr/>
-        </p:nvSpPr>
-        <p:spPr>
-          <a:xfrm>
-            <a:off x="548640" y="658368"/>
-            <a:ext cx="11091672" cy="685800"/>
-          </a:xfrm>
-          <a:prstGeom prst="rect">
-            <a:avLst/>
-          </a:prstGeom>
-          <a:noFill/>
-          <a:ln/>
-        </p:spPr>
-        <p:txBody>
-          <a:bodyPr wrap="square" lIns="0" tIns="0" rIns="0" bIns="0" rtlCol="0" anchor="ctr"/>
-          <a:lstStyle/>
-          <a:p>
-            <a:pPr indent="0" marL="0">
-              <a:buNone/>
-            </a:pPr>
-            <a:r>
-              <a:rPr lang="en-US" sz="2800" b="1" dirty="0">
-                <a:solidFill>
-                  <a:srgbClr val="002B5C"/>
-                </a:solidFill>
-                <a:latin typeface="Cambria" pitchFamily="34" charset="0"/>
-                <a:ea typeface="Cambria" pitchFamily="34" charset="-122"/>
-                <a:cs typeface="Cambria" pitchFamily="34" charset="-120"/>
-              </a:rPr>
-              <a:t>Her numbers vs. the verified data</a:t>
-            </a:r>
-            <a:endParaRPr lang="en-US" sz="2800" dirty="0"/>
-          </a:p>
-        </p:txBody>
-      </p:sp>
-      <p:graphicFrame>
-        <p:nvGraphicFramePr>
-          <p:cNvPr id="13" name="Table 0"/>
-          <p:cNvGraphicFramePr>
-            <a:graphicFrameLocks noGrp="1"/>
-          </p:cNvGraphicFramePr>
-          <p:nvPr>
-            <p:extLst>
-              <p:ext uri="{D42A27DB-BD31-4B8C-83A1-F6EECF244321}">
-                <p14:modId xmlns:p14="http://schemas.microsoft.com/office/powerpoint/2010/main" val="1579011935"/>
-              </p:ext>
-            </p:extLst>
-          </p:nvPr>
-        </p:nvGraphicFramePr>
-        <p:xfrm>
-          <a:off x="548640" y="1572768"/>
-          <a:ext cx="11091672" cy="914400"/>
-        </p:xfrm>
-        <a:graphic>
-          <a:graphicData uri="http://schemas.openxmlformats.org/drawingml/2006/table">
-            <a:tbl>
-              <a:tblPr/>
-              <a:tblGrid>
-                <a:gridCol w="4480560"/>
-                <a:gridCol w="2011680"/>
-                <a:gridCol w="3227832"/>
-                <a:gridCol w="1371600"/>
-              </a:tblGrid>
-              <a:tr h="310896">
-                <a:tc>
-                  <a:txBody>
-                    <a:bodyPr/>
-                    <a:lstStyle/>
-                    <a:p>
-                      <a:pPr indent="0" marL="0">
-                        <a:buNone/>
-                      </a:pPr>
-                      <a:r>
-                        <a:rPr lang="en-US" sz="1050" b="1" dirty="0">
-                          <a:solidFill>
-                            <a:srgbClr val="FFFFFF"/>
-                          </a:solidFill>
-                          <a:latin typeface="Calibri" pitchFamily="34" charset="0"/>
-                          <a:ea typeface="Calibri" pitchFamily="34" charset="-122"/>
-                          <a:cs typeface="Calibri" pitchFamily="34" charset="-120"/>
-                        </a:rPr>
-                        <a:t>Claim in video</a:t>
-                      </a:r>
-                      <a:endParaRPr lang="en-US" sz="1050" dirty="0">
-                        <a:latin typeface="Calibri" charset="0"/>
-                        <a:ea typeface="Calibri" charset="0"/>
-                        <a:cs typeface="Calibri" charset="0"/>
-                      </a:endParaRPr>
-                    </a:p>
-                  </a:txBody>
-                  <a:tcPr marL="91440" marR="91440" marT="45720" marB="45720" anchor="ctr">
-                    <a:lnL w="9525" cap="flat" cmpd="sng" algn="ctr">
-                      <a:solidFill>
-                        <a:srgbClr val="E4E9EF"/>
-                      </a:solidFill>
-                      <a:prstDash val="solid"/>
-                      <a:round/>
-                      <a:headEnd type="none" w="med" len="med"/>
-                      <a:tailEnd type="none" w="med" len="med"/>
-                    </a:lnL>
-                    <a:lnR w="9525" cap="flat" cmpd="sng" algn="ctr">
-                      <a:solidFill>
-                        <a:srgbClr val="E4E9EF"/>
-                      </a:solidFill>
-                      <a:prstDash val="solid"/>
-                      <a:round/>
-                      <a:headEnd type="none" w="med" len="med"/>
-                      <a:tailEnd type="none" w="med" len="med"/>
-                    </a:lnR>
-                    <a:lnT w="9525" cap="flat" cmpd="sng" algn="ctr">
-                      <a:solidFill>
-                        <a:srgbClr val="E4E9EF"/>
-                      </a:solidFill>
-                      <a:prstDash val="solid"/>
-                      <a:round/>
-                      <a:headEnd type="none" w="med" len="med"/>
-                      <a:tailEnd type="none" w="med" len="med"/>
-                    </a:lnT>
-                    <a:lnB w="9525" cap="flat" cmpd="sng" algn="ctr">
-                      <a:solidFill>
-                        <a:srgbClr val="E4E9EF"/>
-                      </a:solidFill>
-                      <a:prstDash val="solid"/>
-                      <a:round/>
-                      <a:headEnd type="none" w="med" len="med"/>
-                      <a:tailEnd type="none" w="med" len="med"/>
-                    </a:lnB>
-                    <a:solidFill>
-                      <a:srgbClr val="002B5C"/>
-                    </a:solidFill>
-                  </a:tcPr>
-                </a:tc>
-                <a:tc>
-                  <a:txBody>
-                    <a:bodyPr/>
-                    <a:lstStyle/>
-                    <a:p>
-                      <a:pPr algn="ctr" indent="0" marL="0">
-                        <a:buNone/>
-                      </a:pPr>
-                      <a:r>
-                        <a:rPr lang="en-US" sz="1050" b="1" dirty="0">
-                          <a:solidFill>
-                            <a:srgbClr val="FFFFFF"/>
-                          </a:solidFill>
-                          <a:latin typeface="Calibri" pitchFamily="34" charset="0"/>
-                          <a:ea typeface="Calibri" pitchFamily="34" charset="-122"/>
-                          <a:cs typeface="Calibri" pitchFamily="34" charset="-120"/>
-                        </a:rPr>
-                        <a:t>Video</a:t>
-                      </a:r>
-                      <a:endParaRPr lang="en-US" sz="1050" dirty="0">
-                        <a:latin typeface="Calibri" charset="0"/>
-                        <a:ea typeface="Calibri" charset="0"/>
-                        <a:cs typeface="Calibri" charset="0"/>
-                      </a:endParaRPr>
-                    </a:p>
-                  </a:txBody>
-                  <a:tcPr marL="91440" marR="91440" marT="45720" marB="45720" anchor="ctr">
-                    <a:lnL w="9525" cap="flat" cmpd="sng" algn="ctr">
-                      <a:solidFill>
-                        <a:srgbClr val="E4E9EF"/>
-                      </a:solidFill>
-                      <a:prstDash val="solid"/>
-                      <a:round/>
-                      <a:headEnd type="none" w="med" len="med"/>
-                      <a:tailEnd type="none" w="med" len="med"/>
-                    </a:lnL>
-                    <a:lnR w="9525" cap="flat" cmpd="sng" algn="ctr">
-                      <a:solidFill>
-                        <a:srgbClr val="E4E9EF"/>
-                      </a:solidFill>
-                      <a:prstDash val="solid"/>
-                      <a:round/>
-                      <a:headEnd type="none" w="med" len="med"/>
-                      <a:tailEnd type="none" w="med" len="med"/>
-                    </a:lnR>
-                    <a:lnT w="9525" cap="flat" cmpd="sng" algn="ctr">
-                      <a:solidFill>
-                        <a:srgbClr val="E4E9EF"/>
-                      </a:solidFill>
-                      <a:prstDash val="solid"/>
-                      <a:round/>
-                      <a:headEnd type="none" w="med" len="med"/>
-                      <a:tailEnd type="none" w="med" len="med"/>
-                    </a:lnT>
-                    <a:lnB w="9525" cap="flat" cmpd="sng" algn="ctr">
-                      <a:solidFill>
-                        <a:srgbClr val="E4E9EF"/>
-                      </a:solidFill>
-                      <a:prstDash val="solid"/>
-                      <a:round/>
-                      <a:headEnd type="none" w="med" len="med"/>
-                      <a:tailEnd type="none" w="med" len="med"/>
-                    </a:lnB>
-                    <a:solidFill>
-                      <a:srgbClr val="002B5C"/>
-                    </a:solidFill>
-                  </a:tcPr>
-                </a:tc>
-                <a:tc>
-                  <a:txBody>
-                    <a:bodyPr/>
-                    <a:lstStyle/>
-                    <a:p>
-                      <a:pPr algn="ctr" indent="0" marL="0">
-                        <a:buNone/>
-                      </a:pPr>
-                      <a:r>
-                        <a:rPr lang="en-US" sz="1050" b="1" dirty="0">
-                          <a:solidFill>
-                            <a:srgbClr val="FFFFFF"/>
-                          </a:solidFill>
-                          <a:latin typeface="Calibri" pitchFamily="34" charset="0"/>
-                          <a:ea typeface="Calibri" pitchFamily="34" charset="-122"/>
-                          <a:cs typeface="Calibri" pitchFamily="34" charset="-120"/>
-                        </a:rPr>
-                        <a:t>Verified / my calc</a:t>
-                      </a:r>
-                      <a:endParaRPr lang="en-US" sz="1050" dirty="0">
-                        <a:latin typeface="Calibri" charset="0"/>
-                        <a:ea typeface="Calibri" charset="0"/>
-                        <a:cs typeface="Calibri" charset="0"/>
-                      </a:endParaRPr>
-                    </a:p>
-                  </a:txBody>
-                  <a:tcPr marL="91440" marR="91440" marT="45720" marB="45720" anchor="ctr">
-                    <a:lnL w="9525" cap="flat" cmpd="sng" algn="ctr">
-                      <a:solidFill>
-                        <a:srgbClr val="E4E9EF"/>
-                      </a:solidFill>
-                      <a:prstDash val="solid"/>
-                      <a:round/>
-                      <a:headEnd type="none" w="med" len="med"/>
-                      <a:tailEnd type="none" w="med" len="med"/>
-                    </a:lnL>
-                    <a:lnR w="9525" cap="flat" cmpd="sng" algn="ctr">
-                      <a:solidFill>
-                        <a:srgbClr val="E4E9EF"/>
-                      </a:solidFill>
-                      <a:prstDash val="solid"/>
-                      <a:round/>
-                      <a:headEnd type="none" w="med" len="med"/>
-                      <a:tailEnd type="none" w="med" len="med"/>
-                    </a:lnR>
-                    <a:lnT w="9525" cap="flat" cmpd="sng" algn="ctr">
-                      <a:solidFill>
-                        <a:srgbClr val="E4E9EF"/>
-                      </a:solidFill>
-                      <a:prstDash val="solid"/>
-                      <a:round/>
-                      <a:headEnd type="none" w="med" len="med"/>
-                      <a:tailEnd type="none" w="med" len="med"/>
-                    </a:lnT>
-                    <a:lnB w="9525" cap="flat" cmpd="sng" algn="ctr">
-                      <a:solidFill>
-                        <a:srgbClr val="E4E9EF"/>
-                      </a:solidFill>
-                      <a:prstDash val="solid"/>
-                      <a:round/>
-                      <a:headEnd type="none" w="med" len="med"/>
-                      <a:tailEnd type="none" w="med" len="med"/>
-                    </a:lnB>
-                    <a:solidFill>
-                      <a:srgbClr val="002B5C"/>
-                    </a:solidFill>
-                  </a:tcPr>
-                </a:tc>
-                <a:tc>
-                  <a:txBody>
-                    <a:bodyPr/>
-                    <a:lstStyle/>
-                    <a:p>
-                      <a:pPr algn="ctr" indent="0" marL="0">
-                        <a:buNone/>
-                      </a:pPr>
-                      <a:r>
-                        <a:rPr lang="en-US" sz="1050" b="1" dirty="0">
-                          <a:solidFill>
-                            <a:srgbClr val="FFFFFF"/>
-                          </a:solidFill>
-                          <a:latin typeface="Calibri" pitchFamily="34" charset="0"/>
-                          <a:ea typeface="Calibri" pitchFamily="34" charset="-122"/>
-                          <a:cs typeface="Calibri" pitchFamily="34" charset="-120"/>
-                        </a:rPr>
-                        <a:t>Verdict</a:t>
-                      </a:r>
-                      <a:endParaRPr lang="en-US" sz="1050" dirty="0">
-                        <a:latin typeface="Calibri" charset="0"/>
-                        <a:ea typeface="Calibri" charset="0"/>
-                        <a:cs typeface="Calibri" charset="0"/>
-                      </a:endParaRPr>
-                    </a:p>
-                  </a:txBody>
-                  <a:tcPr marL="91440" marR="91440" marT="45720" marB="45720" anchor="ctr">
-                    <a:lnL w="9525" cap="flat" cmpd="sng" algn="ctr">
-                      <a:solidFill>
-                        <a:srgbClr val="E4E9EF"/>
-                      </a:solidFill>
-                      <a:prstDash val="solid"/>
-                      <a:round/>
-                      <a:headEnd type="none" w="med" len="med"/>
-                      <a:tailEnd type="none" w="med" len="med"/>
-                    </a:lnL>
-                    <a:lnR w="9525" cap="flat" cmpd="sng" algn="ctr">
-                      <a:solidFill>
-                        <a:srgbClr val="E4E9EF"/>
-                      </a:solidFill>
-                      <a:prstDash val="solid"/>
-                      <a:round/>
-                      <a:headEnd type="none" w="med" len="med"/>
-                      <a:tailEnd type="none" w="med" len="med"/>
-                    </a:lnR>
-                    <a:lnT w="9525" cap="flat" cmpd="sng" algn="ctr">
-                      <a:solidFill>
-                        <a:srgbClr val="E4E9EF"/>
-                      </a:solidFill>
-                      <a:prstDash val="solid"/>
-                      <a:round/>
-                      <a:headEnd type="none" w="med" len="med"/>
-                      <a:tailEnd type="none" w="med" len="med"/>
-                    </a:lnT>
-                    <a:lnB w="9525" cap="flat" cmpd="sng" algn="ctr">
-                      <a:solidFill>
-                        <a:srgbClr val="E4E9EF"/>
-                      </a:solidFill>
-                      <a:prstDash val="solid"/>
-                      <a:round/>
-                      <a:headEnd type="none" w="med" len="med"/>
-                      <a:tailEnd type="none" w="med" len="med"/>
-                    </a:lnB>
-                    <a:solidFill>
-                      <a:srgbClr val="002B5C"/>
-                    </a:solidFill>
-                  </a:tcPr>
-                </a:tc>
-              </a:tr>
-              <a:tr h="310896">
-                <a:tc>
-                  <a:txBody>
-                    <a:bodyPr/>
-                    <a:lstStyle/>
-                    <a:p>
-                      <a:pPr indent="0" marL="0">
-                        <a:buNone/>
-                      </a:pPr>
-                      <a:r>
-                        <a:rPr lang="en-US" sz="1050" dirty="0">
-                          <a:solidFill>
-                            <a:srgbClr val="1C2B3A"/>
-                          </a:solidFill>
-                          <a:latin typeface="Calibri" pitchFamily="34" charset="0"/>
-                          <a:ea typeface="Calibri" pitchFamily="34" charset="-122"/>
-                          <a:cs typeface="Calibri" pitchFamily="34" charset="-120"/>
-                        </a:rPr>
-                        <a:t>Sixers 2025-26 wins → projection</a:t>
-                      </a:r>
-                      <a:endParaRPr lang="en-US" sz="1050" dirty="0">
-                        <a:latin typeface="Calibri" charset="0"/>
-                        <a:ea typeface="Calibri" charset="0"/>
-                        <a:cs typeface="Calibri" charset="0"/>
-                      </a:endParaRPr>
-                    </a:p>
-                  </a:txBody>
-                  <a:tcPr marL="91440" marR="91440" marT="45720" marB="45720" anchor="ctr">
-                    <a:lnL w="9525" cap="flat" cmpd="sng" algn="ctr">
-                      <a:solidFill>
-                        <a:srgbClr val="E4E9EF"/>
-                      </a:solidFill>
-                      <a:prstDash val="solid"/>
-                      <a:round/>
-                      <a:headEnd type="none" w="med" len="med"/>
-                      <a:tailEnd type="none" w="med" len="med"/>
-                    </a:lnL>
-                    <a:lnR w="9525" cap="flat" cmpd="sng" algn="ctr">
-                      <a:solidFill>
-                        <a:srgbClr val="E4E9EF"/>
-                      </a:solidFill>
-                      <a:prstDash val="solid"/>
-                      <a:round/>
-                      <a:headEnd type="none" w="med" len="med"/>
-                      <a:tailEnd type="none" w="med" len="med"/>
-                    </a:lnR>
-                    <a:lnT w="9525" cap="flat" cmpd="sng" algn="ctr">
-                      <a:solidFill>
-                        <a:srgbClr val="E4E9EF"/>
-                      </a:solidFill>
-                      <a:prstDash val="solid"/>
-                      <a:round/>
-                      <a:headEnd type="none" w="med" len="med"/>
-                      <a:tailEnd type="none" w="med" len="med"/>
-                    </a:lnT>
-                    <a:lnB w="9525" cap="flat" cmpd="sng" algn="ctr">
-                      <a:solidFill>
-                        <a:srgbClr val="E4E9EF"/>
-                      </a:solidFill>
-                      <a:prstDash val="solid"/>
-                      <a:round/>
-                      <a:headEnd type="none" w="med" len="med"/>
-                      <a:tailEnd type="none" w="med" len="med"/>
-                    </a:lnB>
-                    <a:solidFill>
-                      <a:srgbClr val="FFFFFF"/>
-                    </a:solidFill>
-                  </a:tcPr>
-                </a:tc>
-                <a:tc>
-                  <a:txBody>
-                    <a:bodyPr/>
-                    <a:lstStyle/>
-                    <a:p>
-                      <a:pPr algn="ctr" indent="0" marL="0">
-                        <a:buNone/>
-                      </a:pPr>
-                      <a:r>
-                        <a:rPr lang="en-US" sz="1050" dirty="0">
-                          <a:solidFill>
-                            <a:srgbClr val="1C2B3A"/>
-                          </a:solidFill>
-                          <a:latin typeface="Calibri" pitchFamily="34" charset="0"/>
-                          <a:ea typeface="Calibri" pitchFamily="34" charset="-122"/>
-                          <a:cs typeface="Calibri" pitchFamily="34" charset="-120"/>
-                        </a:rPr>
-                        <a:t>45 → 51</a:t>
-                      </a:r>
-                      <a:endParaRPr lang="en-US" sz="1050" dirty="0">
-                        <a:latin typeface="Calibri" charset="0"/>
-                        <a:ea typeface="Calibri" charset="0"/>
-                        <a:cs typeface="Calibri" charset="0"/>
-                      </a:endParaRPr>
-                    </a:p>
-                  </a:txBody>
-                  <a:tcPr marL="91440" marR="91440" marT="45720" marB="45720" anchor="ctr">
-                    <a:lnL w="9525" cap="flat" cmpd="sng" algn="ctr">
-                      <a:solidFill>
-                        <a:srgbClr val="E4E9EF"/>
-                      </a:solidFill>
-                      <a:prstDash val="solid"/>
-                      <a:round/>
-                      <a:headEnd type="none" w="med" len="med"/>
-                      <a:tailEnd type="none" w="med" len="med"/>
-                    </a:lnL>
-                    <a:lnR w="9525" cap="flat" cmpd="sng" algn="ctr">
-                      <a:solidFill>
-                        <a:srgbClr val="E4E9EF"/>
-                      </a:solidFill>
-                      <a:prstDash val="solid"/>
-                      <a:round/>
-                      <a:headEnd type="none" w="med" len="med"/>
-                      <a:tailEnd type="none" w="med" len="med"/>
-                    </a:lnR>
-                    <a:lnT w="9525" cap="flat" cmpd="sng" algn="ctr">
-                      <a:solidFill>
-                        <a:srgbClr val="E4E9EF"/>
-                      </a:solidFill>
-                      <a:prstDash val="solid"/>
-                      <a:round/>
-                      <a:headEnd type="none" w="med" len="med"/>
-                      <a:tailEnd type="none" w="med" len="med"/>
-                    </a:lnT>
-                    <a:lnB w="9525" cap="flat" cmpd="sng" algn="ctr">
-                      <a:solidFill>
-                        <a:srgbClr val="E4E9EF"/>
-                      </a:solidFill>
-                      <a:prstDash val="solid"/>
-                      <a:round/>
-                      <a:headEnd type="none" w="med" len="med"/>
-                      <a:tailEnd type="none" w="med" len="med"/>
-                    </a:lnB>
-                    <a:solidFill>
-                      <a:srgbClr val="FFFFFF"/>
-                    </a:solidFill>
-                  </a:tcPr>
-                </a:tc>
-                <a:tc>
-                  <a:txBody>
-                    <a:bodyPr/>
-                    <a:lstStyle/>
-                    <a:p>
-                      <a:pPr algn="ctr" indent="0" marL="0">
-                        <a:buNone/>
-                      </a:pPr>
-                      <a:r>
-                        <a:rPr lang="en-US" sz="1050" dirty="0">
-                          <a:solidFill>
-                            <a:srgbClr val="1C2B3A"/>
-                          </a:solidFill>
-                          <a:latin typeface="Calibri" pitchFamily="34" charset="0"/>
-                          <a:ea typeface="Calibri" pitchFamily="34" charset="-122"/>
-                          <a:cs typeface="Calibri" pitchFamily="34" charset="-120"/>
-                        </a:rPr>
-                        <a:t>45 → 51 (ledger) · mkt 50.5</a:t>
-                      </a:r>
-                      <a:endParaRPr lang="en-US" sz="1050" dirty="0">
-                        <a:latin typeface="Calibri" charset="0"/>
-                        <a:ea typeface="Calibri" charset="0"/>
-                        <a:cs typeface="Calibri" charset="0"/>
-                      </a:endParaRPr>
-                    </a:p>
-                  </a:txBody>
-                  <a:tcPr marL="91440" marR="91440" marT="45720" marB="45720" anchor="ctr">
-                    <a:lnL w="9525" cap="flat" cmpd="sng" algn="ctr">
-                      <a:solidFill>
-                        <a:srgbClr val="E4E9EF"/>
-                      </a:solidFill>
-                      <a:prstDash val="solid"/>
-                      <a:round/>
-                      <a:headEnd type="none" w="med" len="med"/>
-                      <a:tailEnd type="none" w="med" len="med"/>
-                    </a:lnL>
-                    <a:lnR w="9525" cap="flat" cmpd="sng" algn="ctr">
-                      <a:solidFill>
-                        <a:srgbClr val="E4E9EF"/>
-                      </a:solidFill>
-                      <a:prstDash val="solid"/>
-                      <a:round/>
-                      <a:headEnd type="none" w="med" len="med"/>
-                      <a:tailEnd type="none" w="med" len="med"/>
-                    </a:lnR>
-                    <a:lnT w="9525" cap="flat" cmpd="sng" algn="ctr">
-                      <a:solidFill>
-                        <a:srgbClr val="E4E9EF"/>
-                      </a:solidFill>
-                      <a:prstDash val="solid"/>
-                      <a:round/>
-                      <a:headEnd type="none" w="med" len="med"/>
-                      <a:tailEnd type="none" w="med" len="med"/>
-                    </a:lnT>
-                    <a:lnB w="9525" cap="flat" cmpd="sng" algn="ctr">
-                      <a:solidFill>
-                        <a:srgbClr val="E4E9EF"/>
-                      </a:solidFill>
-                      <a:prstDash val="solid"/>
-                      <a:round/>
-                      <a:headEnd type="none" w="med" len="med"/>
-                      <a:tailEnd type="none" w="med" len="med"/>
-                    </a:lnB>
-                    <a:solidFill>
-                      <a:srgbClr val="FFFFFF"/>
-                    </a:solidFill>
-                  </a:tcPr>
-                </a:tc>
-                <a:tc>
-                  <a:txBody>
-                    <a:bodyPr/>
-                    <a:lstStyle/>
-                    <a:p>
-                      <a:pPr algn="ctr" indent="0" marL="0">
-                        <a:buNone/>
-                      </a:pPr>
-                      <a:r>
-                        <a:rPr lang="en-US" sz="1050" b="1" dirty="0">
-                          <a:solidFill>
-                            <a:srgbClr val="1E7A46"/>
-                          </a:solidFill>
-                          <a:latin typeface="Calibri" pitchFamily="34" charset="0"/>
-                          <a:ea typeface="Calibri" pitchFamily="34" charset="-122"/>
-                          <a:cs typeface="Calibri" pitchFamily="34" charset="-120"/>
-                        </a:rPr>
-                        <a:t>exact</a:t>
-                      </a:r>
-                      <a:endParaRPr lang="en-US" sz="1050" dirty="0">
-                        <a:latin typeface="Calibri" charset="0"/>
-                        <a:ea typeface="Calibri" charset="0"/>
-                        <a:cs typeface="Calibri" charset="0"/>
-                      </a:endParaRPr>
-                    </a:p>
-                  </a:txBody>
-                  <a:tcPr marL="91440" marR="91440" marT="45720" marB="45720" anchor="ctr">
-                    <a:lnL w="9525" cap="flat" cmpd="sng" algn="ctr">
-                      <a:solidFill>
-                        <a:srgbClr val="E4E9EF"/>
-                      </a:solidFill>
-                      <a:prstDash val="solid"/>
-                      <a:round/>
-                      <a:headEnd type="none" w="med" len="med"/>
-                      <a:tailEnd type="none" w="med" len="med"/>
-                    </a:lnL>
-                    <a:lnR w="9525" cap="flat" cmpd="sng" algn="ctr">
-                      <a:solidFill>
-                        <a:srgbClr val="E4E9EF"/>
-                      </a:solidFill>
-                      <a:prstDash val="solid"/>
-                      <a:round/>
-                      <a:headEnd type="none" w="med" len="med"/>
-                      <a:tailEnd type="none" w="med" len="med"/>
-                    </a:lnR>
-                    <a:lnT w="9525" cap="flat" cmpd="sng" algn="ctr">
-                      <a:solidFill>
-                        <a:srgbClr val="E4E9EF"/>
-                      </a:solidFill>
-                      <a:prstDash val="solid"/>
-                      <a:round/>
-                      <a:headEnd type="none" w="med" len="med"/>
-                      <a:tailEnd type="none" w="med" len="med"/>
-                    </a:lnT>
-                    <a:lnB w="9525" cap="flat" cmpd="sng" algn="ctr">
-                      <a:solidFill>
-                        <a:srgbClr val="E4E9EF"/>
-                      </a:solidFill>
-                      <a:prstDash val="solid"/>
-                      <a:round/>
-                      <a:headEnd type="none" w="med" len="med"/>
-                      <a:tailEnd type="none" w="med" len="med"/>
-                    </a:lnB>
-                    <a:solidFill>
-                      <a:srgbClr val="FFFFFF"/>
-                    </a:solidFill>
-                  </a:tcPr>
-                </a:tc>
-              </a:tr>
-              <a:tr h="310896">
-                <a:tc>
-                  <a:txBody>
-                    <a:bodyPr/>
-                    <a:lstStyle/>
-                    <a:p>
-                      <a:pPr indent="0" marL="0">
-                        <a:buNone/>
-                      </a:pPr>
-                      <a:r>
-                        <a:rPr lang="en-US" sz="1050" dirty="0">
-                          <a:solidFill>
-                            <a:srgbClr val="1C2B3A"/>
-                          </a:solidFill>
-                          <a:latin typeface="Calibri" pitchFamily="34" charset="0"/>
-                          <a:ea typeface="Calibri" pitchFamily="34" charset="-122"/>
-                          <a:cs typeface="Calibri" pitchFamily="34" charset="-120"/>
-                        </a:rPr>
-                        <a:t>Maxey unassisted share (n=694) / league</a:t>
-                      </a:r>
-                      <a:endParaRPr lang="en-US" sz="1050" dirty="0">
-                        <a:latin typeface="Calibri" charset="0"/>
-                        <a:ea typeface="Calibri" charset="0"/>
-                        <a:cs typeface="Calibri" charset="0"/>
-                      </a:endParaRPr>
-                    </a:p>
-                  </a:txBody>
-                  <a:tcPr marL="91440" marR="91440" marT="45720" marB="45720" anchor="ctr">
-                    <a:lnL w="9525" cap="flat" cmpd="sng" algn="ctr">
-                      <a:solidFill>
-                        <a:srgbClr val="E4E9EF"/>
-                      </a:solidFill>
-                      <a:prstDash val="solid"/>
-                      <a:round/>
-                      <a:headEnd type="none" w="med" len="med"/>
-                      <a:tailEnd type="none" w="med" len="med"/>
-                    </a:lnL>
-                    <a:lnR w="9525" cap="flat" cmpd="sng" algn="ctr">
-                      <a:solidFill>
-                        <a:srgbClr val="E4E9EF"/>
-                      </a:solidFill>
-                      <a:prstDash val="solid"/>
-                      <a:round/>
-                      <a:headEnd type="none" w="med" len="med"/>
-                      <a:tailEnd type="none" w="med" len="med"/>
-                    </a:lnR>
-                    <a:lnT w="9525" cap="flat" cmpd="sng" algn="ctr">
-                      <a:solidFill>
-                        <a:srgbClr val="E4E9EF"/>
-                      </a:solidFill>
-                      <a:prstDash val="solid"/>
-                      <a:round/>
-                      <a:headEnd type="none" w="med" len="med"/>
-                      <a:tailEnd type="none" w="med" len="med"/>
-                    </a:lnT>
-                    <a:lnB w="9525" cap="flat" cmpd="sng" algn="ctr">
-                      <a:solidFill>
-                        <a:srgbClr val="E4E9EF"/>
-                      </a:solidFill>
-                      <a:prstDash val="solid"/>
-                      <a:round/>
-                      <a:headEnd type="none" w="med" len="med"/>
-                      <a:tailEnd type="none" w="med" len="med"/>
-                    </a:lnB>
-                    <a:solidFill>
-                      <a:srgbClr val="FFFFFF"/>
-                    </a:solidFill>
-                  </a:tcPr>
-                </a:tc>
-                <a:tc>
-                  <a:txBody>
-                    <a:bodyPr/>
-                    <a:lstStyle/>
-                    <a:p>
-                      <a:pPr algn="ctr" indent="0" marL="0">
-                        <a:buNone/>
-                      </a:pPr>
-                      <a:r>
-                        <a:rPr lang="en-US" sz="1050" dirty="0">
-                          <a:solidFill>
-                            <a:srgbClr val="1C2B3A"/>
-                          </a:solidFill>
-                          <a:latin typeface="Calibri" pitchFamily="34" charset="0"/>
-                          <a:ea typeface="Calibri" pitchFamily="34" charset="-122"/>
-                          <a:cs typeface="Calibri" pitchFamily="34" charset="-120"/>
-                        </a:rPr>
-                        <a:t>55% / 36%</a:t>
-                      </a:r>
-                      <a:endParaRPr lang="en-US" sz="1050" dirty="0">
-                        <a:latin typeface="Calibri" charset="0"/>
-                        <a:ea typeface="Calibri" charset="0"/>
-                        <a:cs typeface="Calibri" charset="0"/>
-                      </a:endParaRPr>
-                    </a:p>
-                  </a:txBody>
-                  <a:tcPr marL="91440" marR="91440" marT="45720" marB="45720" anchor="ctr">
-                    <a:lnL w="9525" cap="flat" cmpd="sng" algn="ctr">
-                      <a:solidFill>
-                        <a:srgbClr val="E4E9EF"/>
-                      </a:solidFill>
-                      <a:prstDash val="solid"/>
-                      <a:round/>
-                      <a:headEnd type="none" w="med" len="med"/>
-                      <a:tailEnd type="none" w="med" len="med"/>
-                    </a:lnL>
-                    <a:lnR w="9525" cap="flat" cmpd="sng" algn="ctr">
-                      <a:solidFill>
-                        <a:srgbClr val="E4E9EF"/>
-                      </a:solidFill>
-                      <a:prstDash val="solid"/>
-                      <a:round/>
-                      <a:headEnd type="none" w="med" len="med"/>
-                      <a:tailEnd type="none" w="med" len="med"/>
-                    </a:lnR>
-                    <a:lnT w="9525" cap="flat" cmpd="sng" algn="ctr">
-                      <a:solidFill>
-                        <a:srgbClr val="E4E9EF"/>
-                      </a:solidFill>
-                      <a:prstDash val="solid"/>
-                      <a:round/>
-                      <a:headEnd type="none" w="med" len="med"/>
-                      <a:tailEnd type="none" w="med" len="med"/>
-                    </a:lnT>
-                    <a:lnB w="9525" cap="flat" cmpd="sng" algn="ctr">
-                      <a:solidFill>
-                        <a:srgbClr val="E4E9EF"/>
-                      </a:solidFill>
-                      <a:prstDash val="solid"/>
-                      <a:round/>
-                      <a:headEnd type="none" w="med" len="med"/>
-                      <a:tailEnd type="none" w="med" len="med"/>
-                    </a:lnB>
-                    <a:solidFill>
-                      <a:srgbClr val="FFFFFF"/>
-                    </a:solidFill>
-                  </a:tcPr>
-                </a:tc>
-                <a:tc>
-                  <a:txBody>
-                    <a:bodyPr/>
-                    <a:lstStyle/>
-                    <a:p>
-                      <a:pPr algn="ctr" indent="0" marL="0">
-                        <a:buNone/>
-                      </a:pPr>
-                      <a:r>
-                        <a:rPr lang="en-US" sz="1050" dirty="0">
-                          <a:solidFill>
-                            <a:srgbClr val="1C2B3A"/>
-                          </a:solidFill>
-                          <a:latin typeface="Calibri" pitchFamily="34" charset="0"/>
-                          <a:ea typeface="Calibri" pitchFamily="34" charset="-122"/>
-                          <a:cs typeface="Calibri" pitchFamily="34" charset="-120"/>
-                        </a:rPr>
-                        <a:t>55.3% / 36.3%</a:t>
-                      </a:r>
-                      <a:endParaRPr lang="en-US" sz="1050" dirty="0">
-                        <a:latin typeface="Calibri" charset="0"/>
-                        <a:ea typeface="Calibri" charset="0"/>
-                        <a:cs typeface="Calibri" charset="0"/>
-                      </a:endParaRPr>
-                    </a:p>
-                  </a:txBody>
-                  <a:tcPr marL="91440" marR="91440" marT="45720" marB="45720" anchor="ctr">
-                    <a:lnL w="9525" cap="flat" cmpd="sng" algn="ctr">
-                      <a:solidFill>
-                        <a:srgbClr val="E4E9EF"/>
-                      </a:solidFill>
-                      <a:prstDash val="solid"/>
-                      <a:round/>
-                      <a:headEnd type="none" w="med" len="med"/>
-                      <a:tailEnd type="none" w="med" len="med"/>
-                    </a:lnL>
-                    <a:lnR w="9525" cap="flat" cmpd="sng" algn="ctr">
-                      <a:solidFill>
-                        <a:srgbClr val="E4E9EF"/>
-                      </a:solidFill>
-                      <a:prstDash val="solid"/>
-                      <a:round/>
-                      <a:headEnd type="none" w="med" len="med"/>
-                      <a:tailEnd type="none" w="med" len="med"/>
-                    </a:lnR>
-                    <a:lnT w="9525" cap="flat" cmpd="sng" algn="ctr">
-                      <a:solidFill>
-                        <a:srgbClr val="E4E9EF"/>
-                      </a:solidFill>
-                      <a:prstDash val="solid"/>
-                      <a:round/>
-                      <a:headEnd type="none" w="med" len="med"/>
-                      <a:tailEnd type="none" w="med" len="med"/>
-                    </a:lnT>
-                    <a:lnB w="9525" cap="flat" cmpd="sng" algn="ctr">
-                      <a:solidFill>
-                        <a:srgbClr val="E4E9EF"/>
-                      </a:solidFill>
-                      <a:prstDash val="solid"/>
-                      <a:round/>
-                      <a:headEnd type="none" w="med" len="med"/>
-                      <a:tailEnd type="none" w="med" len="med"/>
-                    </a:lnB>
-                    <a:solidFill>
-                      <a:srgbClr val="FFFFFF"/>
-                    </a:solidFill>
-                  </a:tcPr>
-                </a:tc>
-                <a:tc>
-                  <a:txBody>
-                    <a:bodyPr/>
-                    <a:lstStyle/>
-                    <a:p>
-                      <a:pPr algn="ctr" indent="0" marL="0">
-                        <a:buNone/>
-                      </a:pPr>
-                      <a:r>
-                        <a:rPr lang="en-US" sz="1050" b="1" dirty="0">
-                          <a:solidFill>
-                            <a:srgbClr val="1E7A46"/>
-                          </a:solidFill>
-                          <a:latin typeface="Calibri" pitchFamily="34" charset="0"/>
-                          <a:ea typeface="Calibri" pitchFamily="34" charset="-122"/>
-                          <a:cs typeface="Calibri" pitchFamily="34" charset="-120"/>
-                        </a:rPr>
-                        <a:t>exact</a:t>
-                      </a:r>
-                      <a:endParaRPr lang="en-US" sz="1050" dirty="0">
-                        <a:latin typeface="Calibri" charset="0"/>
-                        <a:ea typeface="Calibri" charset="0"/>
-                        <a:cs typeface="Calibri" charset="0"/>
-                      </a:endParaRPr>
-                    </a:p>
-                  </a:txBody>
-                  <a:tcPr marL="91440" marR="91440" marT="45720" marB="45720" anchor="ctr">
-                    <a:lnL w="9525" cap="flat" cmpd="sng" algn="ctr">
-                      <a:solidFill>
-                        <a:srgbClr val="E4E9EF"/>
-                      </a:solidFill>
-                      <a:prstDash val="solid"/>
-                      <a:round/>
-                      <a:headEnd type="none" w="med" len="med"/>
-                      <a:tailEnd type="none" w="med" len="med"/>
-                    </a:lnL>
-                    <a:lnR w="9525" cap="flat" cmpd="sng" algn="ctr">
-                      <a:solidFill>
-                        <a:srgbClr val="E4E9EF"/>
-                      </a:solidFill>
-                      <a:prstDash val="solid"/>
-                      <a:round/>
-                      <a:headEnd type="none" w="med" len="med"/>
-                      <a:tailEnd type="none" w="med" len="med"/>
-                    </a:lnR>
-                    <a:lnT w="9525" cap="flat" cmpd="sng" algn="ctr">
-                      <a:solidFill>
-                        <a:srgbClr val="E4E9EF"/>
-                      </a:solidFill>
-                      <a:prstDash val="solid"/>
-                      <a:round/>
-                      <a:headEnd type="none" w="med" len="med"/>
-                      <a:tailEnd type="none" w="med" len="med"/>
-                    </a:lnT>
-                    <a:lnB w="9525" cap="flat" cmpd="sng" algn="ctr">
-                      <a:solidFill>
-                        <a:srgbClr val="E4E9EF"/>
-                      </a:solidFill>
-                      <a:prstDash val="solid"/>
-                      <a:round/>
-                      <a:headEnd type="none" w="med" len="med"/>
-                      <a:tailEnd type="none" w="med" len="med"/>
-                    </a:lnB>
-                    <a:solidFill>
-                      <a:srgbClr val="FFFFFF"/>
-                    </a:solidFill>
-                  </a:tcPr>
-                </a:tc>
-              </a:tr>
-              <a:tr h="310896">
-                <a:tc>
-                  <a:txBody>
-                    <a:bodyPr/>
-                    <a:lstStyle/>
-                    <a:p>
-                      <a:pPr indent="0" marL="0">
-                        <a:buNone/>
-                      </a:pPr>
-                      <a:r>
-                        <a:rPr lang="en-US" sz="1050" dirty="0">
-                          <a:solidFill>
-                            <a:srgbClr val="1C2B3A"/>
-                          </a:solidFill>
-                          <a:latin typeface="Calibri" pitchFamily="34" charset="0"/>
-                          <a:ea typeface="Calibri" pitchFamily="34" charset="-122"/>
-                          <a:cs typeface="Calibri" pitchFamily="34" charset="-120"/>
-                        </a:rPr>
-                        <a:t>Maxey projected with LeBron</a:t>
-                      </a:r>
-                      <a:endParaRPr lang="en-US" sz="1050" dirty="0">
-                        <a:latin typeface="Calibri" charset="0"/>
-                        <a:ea typeface="Calibri" charset="0"/>
-                        <a:cs typeface="Calibri" charset="0"/>
-                      </a:endParaRPr>
-                    </a:p>
-                  </a:txBody>
-                  <a:tcPr marL="91440" marR="91440" marT="45720" marB="45720" anchor="ctr">
-                    <a:lnL w="9525" cap="flat" cmpd="sng" algn="ctr">
-                      <a:solidFill>
-                        <a:srgbClr val="E4E9EF"/>
-                      </a:solidFill>
-                      <a:prstDash val="solid"/>
-                      <a:round/>
-                      <a:headEnd type="none" w="med" len="med"/>
-                      <a:tailEnd type="none" w="med" len="med"/>
-                    </a:lnL>
-                    <a:lnR w="9525" cap="flat" cmpd="sng" algn="ctr">
-                      <a:solidFill>
-                        <a:srgbClr val="E4E9EF"/>
-                      </a:solidFill>
-                      <a:prstDash val="solid"/>
-                      <a:round/>
-                      <a:headEnd type="none" w="med" len="med"/>
-                      <a:tailEnd type="none" w="med" len="med"/>
-                    </a:lnR>
-                    <a:lnT w="9525" cap="flat" cmpd="sng" algn="ctr">
-                      <a:solidFill>
-                        <a:srgbClr val="E4E9EF"/>
-                      </a:solidFill>
-                      <a:prstDash val="solid"/>
-                      <a:round/>
-                      <a:headEnd type="none" w="med" len="med"/>
-                      <a:tailEnd type="none" w="med" len="med"/>
-                    </a:lnT>
-                    <a:lnB w="9525" cap="flat" cmpd="sng" algn="ctr">
-                      <a:solidFill>
-                        <a:srgbClr val="E4E9EF"/>
-                      </a:solidFill>
-                      <a:prstDash val="solid"/>
-                      <a:round/>
-                      <a:headEnd type="none" w="med" len="med"/>
-                      <a:tailEnd type="none" w="med" len="med"/>
-                    </a:lnB>
-                    <a:solidFill>
-                      <a:srgbClr val="FFFFFF"/>
-                    </a:solidFill>
-                  </a:tcPr>
-                </a:tc>
-                <a:tc>
-                  <a:txBody>
-                    <a:bodyPr/>
-                    <a:lstStyle/>
-                    <a:p>
-                      <a:pPr algn="ctr" indent="0" marL="0">
-                        <a:buNone/>
-                      </a:pPr>
-                      <a:r>
-                        <a:rPr lang="en-US" sz="1050" dirty="0">
-                          <a:solidFill>
-                            <a:srgbClr val="1C2B3A"/>
-                          </a:solidFill>
-                          <a:latin typeface="Calibri" pitchFamily="34" charset="0"/>
-                          <a:ea typeface="Calibri" pitchFamily="34" charset="-122"/>
-                          <a:cs typeface="Calibri" pitchFamily="34" charset="-120"/>
-                        </a:rPr>
-                        <a:t>45%</a:t>
-                      </a:r>
-                      <a:endParaRPr lang="en-US" sz="1050" dirty="0">
-                        <a:latin typeface="Calibri" charset="0"/>
-                        <a:ea typeface="Calibri" charset="0"/>
-                        <a:cs typeface="Calibri" charset="0"/>
-                      </a:endParaRPr>
-                    </a:p>
-                  </a:txBody>
-                  <a:tcPr marL="91440" marR="91440" marT="45720" marB="45720" anchor="ctr">
-                    <a:lnL w="9525" cap="flat" cmpd="sng" algn="ctr">
-                      <a:solidFill>
-                        <a:srgbClr val="E4E9EF"/>
-                      </a:solidFill>
-                      <a:prstDash val="solid"/>
-                      <a:round/>
-                      <a:headEnd type="none" w="med" len="med"/>
-                      <a:tailEnd type="none" w="med" len="med"/>
-                    </a:lnL>
-                    <a:lnR w="9525" cap="flat" cmpd="sng" algn="ctr">
-                      <a:solidFill>
-                        <a:srgbClr val="E4E9EF"/>
-                      </a:solidFill>
-                      <a:prstDash val="solid"/>
-                      <a:round/>
-                      <a:headEnd type="none" w="med" len="med"/>
-                      <a:tailEnd type="none" w="med" len="med"/>
-                    </a:lnR>
-                    <a:lnT w="9525" cap="flat" cmpd="sng" algn="ctr">
-                      <a:solidFill>
-                        <a:srgbClr val="E4E9EF"/>
-                      </a:solidFill>
-                      <a:prstDash val="solid"/>
-                      <a:round/>
-                      <a:headEnd type="none" w="med" len="med"/>
-                      <a:tailEnd type="none" w="med" len="med"/>
-                    </a:lnT>
-                    <a:lnB w="9525" cap="flat" cmpd="sng" algn="ctr">
-                      <a:solidFill>
-                        <a:srgbClr val="E4E9EF"/>
-                      </a:solidFill>
-                      <a:prstDash val="solid"/>
-                      <a:round/>
-                      <a:headEnd type="none" w="med" len="med"/>
-                      <a:tailEnd type="none" w="med" len="med"/>
-                    </a:lnB>
-                    <a:solidFill>
-                      <a:srgbClr val="FFFFFF"/>
-                    </a:solidFill>
-                  </a:tcPr>
-                </a:tc>
-                <a:tc>
-                  <a:txBody>
-                    <a:bodyPr/>
-                    <a:lstStyle/>
-                    <a:p>
-                      <a:pPr algn="ctr" indent="0" marL="0">
-                        <a:buNone/>
-                      </a:pPr>
-                      <a:r>
-                        <a:rPr lang="en-US" sz="1050" dirty="0">
-                          <a:solidFill>
-                            <a:srgbClr val="1C2B3A"/>
-                          </a:solidFill>
-                          <a:latin typeface="Calibri" pitchFamily="34" charset="0"/>
-                          <a:ea typeface="Calibri" pitchFamily="34" charset="-122"/>
-                          <a:cs typeface="Calibri" pitchFamily="34" charset="-120"/>
-                        </a:rPr>
-                        <a:t>46.9% (range 43-54)</a:t>
-                      </a:r>
-                      <a:endParaRPr lang="en-US" sz="1050" dirty="0">
-                        <a:latin typeface="Calibri" charset="0"/>
-                        <a:ea typeface="Calibri" charset="0"/>
-                        <a:cs typeface="Calibri" charset="0"/>
-                      </a:endParaRPr>
-                    </a:p>
-                  </a:txBody>
-                  <a:tcPr marL="91440" marR="91440" marT="45720" marB="45720" anchor="ctr">
-                    <a:lnL w="9525" cap="flat" cmpd="sng" algn="ctr">
-                      <a:solidFill>
-                        <a:srgbClr val="E4E9EF"/>
-                      </a:solidFill>
-                      <a:prstDash val="solid"/>
-                      <a:round/>
-                      <a:headEnd type="none" w="med" len="med"/>
-                      <a:tailEnd type="none" w="med" len="med"/>
-                    </a:lnL>
-                    <a:lnR w="9525" cap="flat" cmpd="sng" algn="ctr">
-                      <a:solidFill>
-                        <a:srgbClr val="E4E9EF"/>
-                      </a:solidFill>
-                      <a:prstDash val="solid"/>
-                      <a:round/>
-                      <a:headEnd type="none" w="med" len="med"/>
-                      <a:tailEnd type="none" w="med" len="med"/>
-                    </a:lnR>
-                    <a:lnT w="9525" cap="flat" cmpd="sng" algn="ctr">
-                      <a:solidFill>
-                        <a:srgbClr val="E4E9EF"/>
-                      </a:solidFill>
-                      <a:prstDash val="solid"/>
-                      <a:round/>
-                      <a:headEnd type="none" w="med" len="med"/>
-                      <a:tailEnd type="none" w="med" len="med"/>
-                    </a:lnT>
-                    <a:lnB w="9525" cap="flat" cmpd="sng" algn="ctr">
-                      <a:solidFill>
-                        <a:srgbClr val="E4E9EF"/>
-                      </a:solidFill>
-                      <a:prstDash val="solid"/>
-                      <a:round/>
-                      <a:headEnd type="none" w="med" len="med"/>
-                      <a:tailEnd type="none" w="med" len="med"/>
-                    </a:lnB>
-                    <a:solidFill>
-                      <a:srgbClr val="FFFFFF"/>
-                    </a:solidFill>
-                  </a:tcPr>
-                </a:tc>
-                <a:tc>
-                  <a:txBody>
-                    <a:bodyPr/>
-                    <a:lstStyle/>
-                    <a:p>
-                      <a:pPr algn="ctr" indent="0" marL="0">
-                        <a:buNone/>
-                      </a:pPr>
-                      <a:r>
-                        <a:rPr lang="en-US" sz="1050" b="1" dirty="0">
-                          <a:solidFill>
-                            <a:srgbClr val="1E7A46"/>
-                          </a:solidFill>
-                          <a:latin typeface="Calibri" pitchFamily="34" charset="0"/>
-                          <a:ea typeface="Calibri" pitchFamily="34" charset="-122"/>
-                          <a:cs typeface="Calibri" pitchFamily="34" charset="-120"/>
-                        </a:rPr>
-                        <a:t>close</a:t>
-                      </a:r>
-                      <a:endParaRPr lang="en-US" sz="1050" dirty="0">
-                        <a:latin typeface="Calibri" charset="0"/>
-                        <a:ea typeface="Calibri" charset="0"/>
-                        <a:cs typeface="Calibri" charset="0"/>
-                      </a:endParaRPr>
-                    </a:p>
-                  </a:txBody>
-                  <a:tcPr marL="91440" marR="91440" marT="45720" marB="45720" anchor="ctr">
-                    <a:lnL w="9525" cap="flat" cmpd="sng" algn="ctr">
-                      <a:solidFill>
-                        <a:srgbClr val="E4E9EF"/>
-                      </a:solidFill>
-                      <a:prstDash val="solid"/>
-                      <a:round/>
-                      <a:headEnd type="none" w="med" len="med"/>
-                      <a:tailEnd type="none" w="med" len="med"/>
-                    </a:lnL>
-                    <a:lnR w="9525" cap="flat" cmpd="sng" algn="ctr">
-                      <a:solidFill>
-                        <a:srgbClr val="E4E9EF"/>
-                      </a:solidFill>
-                      <a:prstDash val="solid"/>
-                      <a:round/>
-                      <a:headEnd type="none" w="med" len="med"/>
-                      <a:tailEnd type="none" w="med" len="med"/>
-                    </a:lnR>
-                    <a:lnT w="9525" cap="flat" cmpd="sng" algn="ctr">
-                      <a:solidFill>
-                        <a:srgbClr val="E4E9EF"/>
-                      </a:solidFill>
-                      <a:prstDash val="solid"/>
-                      <a:round/>
-                      <a:headEnd type="none" w="med" len="med"/>
-                      <a:tailEnd type="none" w="med" len="med"/>
-                    </a:lnT>
-                    <a:lnB w="9525" cap="flat" cmpd="sng" algn="ctr">
-                      <a:solidFill>
-                        <a:srgbClr val="E4E9EF"/>
-                      </a:solidFill>
-                      <a:prstDash val="solid"/>
-                      <a:round/>
-                      <a:headEnd type="none" w="med" len="med"/>
-                      <a:tailEnd type="none" w="med" len="med"/>
-                    </a:lnB>
-                    <a:solidFill>
-                      <a:srgbClr val="FFFFFF"/>
-                    </a:solidFill>
-                  </a:tcPr>
-                </a:tc>
-              </a:tr>
-              <a:tr h="310896">
-                <a:tc>
-                  <a:txBody>
-                    <a:bodyPr/>
-                    <a:lstStyle/>
-                    <a:p>
-                      <a:pPr indent="0" marL="0">
-                        <a:buNone/>
-                      </a:pPr>
-                      <a:r>
-                        <a:rPr lang="en-US" sz="1050" dirty="0">
-                          <a:solidFill>
-                            <a:srgbClr val="1C2B3A"/>
-                          </a:solidFill>
-                          <a:latin typeface="Calibri" pitchFamily="34" charset="0"/>
-                          <a:ea typeface="Calibri" pitchFamily="34" charset="-122"/>
-                          <a:cs typeface="Calibri" pitchFamily="34" charset="-120"/>
-                        </a:rPr>
-                        <a:t>Brown assisted, 2025-26 / 2023-24</a:t>
-                      </a:r>
-                      <a:endParaRPr lang="en-US" sz="1050" dirty="0">
-                        <a:latin typeface="Calibri" charset="0"/>
-                        <a:ea typeface="Calibri" charset="0"/>
-                        <a:cs typeface="Calibri" charset="0"/>
-                      </a:endParaRPr>
-                    </a:p>
-                  </a:txBody>
-                  <a:tcPr marL="91440" marR="91440" marT="45720" marB="45720" anchor="ctr">
-                    <a:lnL w="9525" cap="flat" cmpd="sng" algn="ctr">
-                      <a:solidFill>
-                        <a:srgbClr val="E4E9EF"/>
-                      </a:solidFill>
-                      <a:prstDash val="solid"/>
-                      <a:round/>
-                      <a:headEnd type="none" w="med" len="med"/>
-                      <a:tailEnd type="none" w="med" len="med"/>
-                    </a:lnL>
-                    <a:lnR w="9525" cap="flat" cmpd="sng" algn="ctr">
-                      <a:solidFill>
-                        <a:srgbClr val="E4E9EF"/>
-                      </a:solidFill>
-                      <a:prstDash val="solid"/>
-                      <a:round/>
-                      <a:headEnd type="none" w="med" len="med"/>
-                      <a:tailEnd type="none" w="med" len="med"/>
-                    </a:lnR>
-                    <a:lnT w="9525" cap="flat" cmpd="sng" algn="ctr">
-                      <a:solidFill>
-                        <a:srgbClr val="E4E9EF"/>
-                      </a:solidFill>
-                      <a:prstDash val="solid"/>
-                      <a:round/>
-                      <a:headEnd type="none" w="med" len="med"/>
-                      <a:tailEnd type="none" w="med" len="med"/>
-                    </a:lnT>
-                    <a:lnB w="9525" cap="flat" cmpd="sng" algn="ctr">
-                      <a:solidFill>
-                        <a:srgbClr val="E4E9EF"/>
-                      </a:solidFill>
-                      <a:prstDash val="solid"/>
-                      <a:round/>
-                      <a:headEnd type="none" w="med" len="med"/>
-                      <a:tailEnd type="none" w="med" len="med"/>
-                    </a:lnB>
-                    <a:solidFill>
-                      <a:srgbClr val="FFFFFF"/>
-                    </a:solidFill>
-                  </a:tcPr>
-                </a:tc>
-                <a:tc>
-                  <a:txBody>
-                    <a:bodyPr/>
-                    <a:lstStyle/>
-                    <a:p>
-                      <a:pPr algn="ctr" indent="0" marL="0">
-                        <a:buNone/>
-                      </a:pPr>
-                      <a:r>
-                        <a:rPr lang="en-US" sz="1050" dirty="0">
-                          <a:solidFill>
-                            <a:srgbClr val="1C2B3A"/>
-                          </a:solidFill>
-                          <a:latin typeface="Calibri" pitchFamily="34" charset="0"/>
-                          <a:ea typeface="Calibri" pitchFamily="34" charset="-122"/>
-                          <a:cs typeface="Calibri" pitchFamily="34" charset="-120"/>
-                        </a:rPr>
-                        <a:t>36% / 46%</a:t>
-                      </a:r>
-                      <a:endParaRPr lang="en-US" sz="1050" dirty="0">
-                        <a:latin typeface="Calibri" charset="0"/>
-                        <a:ea typeface="Calibri" charset="0"/>
-                        <a:cs typeface="Calibri" charset="0"/>
-                      </a:endParaRPr>
-                    </a:p>
-                  </a:txBody>
-                  <a:tcPr marL="91440" marR="91440" marT="45720" marB="45720" anchor="ctr">
-                    <a:lnL w="9525" cap="flat" cmpd="sng" algn="ctr">
-                      <a:solidFill>
-                        <a:srgbClr val="E4E9EF"/>
-                      </a:solidFill>
-                      <a:prstDash val="solid"/>
-                      <a:round/>
-                      <a:headEnd type="none" w="med" len="med"/>
-                      <a:tailEnd type="none" w="med" len="med"/>
-                    </a:lnL>
-                    <a:lnR w="9525" cap="flat" cmpd="sng" algn="ctr">
-                      <a:solidFill>
-                        <a:srgbClr val="E4E9EF"/>
-                      </a:solidFill>
-                      <a:prstDash val="solid"/>
-                      <a:round/>
-                      <a:headEnd type="none" w="med" len="med"/>
-                      <a:tailEnd type="none" w="med" len="med"/>
-                    </a:lnR>
-                    <a:lnT w="9525" cap="flat" cmpd="sng" algn="ctr">
-                      <a:solidFill>
-                        <a:srgbClr val="E4E9EF"/>
-                      </a:solidFill>
-                      <a:prstDash val="solid"/>
-                      <a:round/>
-                      <a:headEnd type="none" w="med" len="med"/>
-                      <a:tailEnd type="none" w="med" len="med"/>
-                    </a:lnT>
-                    <a:lnB w="9525" cap="flat" cmpd="sng" algn="ctr">
-                      <a:solidFill>
-                        <a:srgbClr val="E4E9EF"/>
-                      </a:solidFill>
-                      <a:prstDash val="solid"/>
-                      <a:round/>
-                      <a:headEnd type="none" w="med" len="med"/>
-                      <a:tailEnd type="none" w="med" len="med"/>
-                    </a:lnB>
-                    <a:solidFill>
-                      <a:srgbClr val="FFFFFF"/>
-                    </a:solidFill>
-                  </a:tcPr>
-                </a:tc>
-                <a:tc>
-                  <a:txBody>
-                    <a:bodyPr/>
-                    <a:lstStyle/>
-                    <a:p>
-                      <a:pPr algn="ctr" indent="0" marL="0">
-                        <a:buNone/>
-                      </a:pPr>
-                      <a:r>
-                        <a:rPr lang="en-US" sz="1050" dirty="0">
-                          <a:solidFill>
-                            <a:srgbClr val="1C2B3A"/>
-                          </a:solidFill>
-                          <a:latin typeface="Calibri" pitchFamily="34" charset="0"/>
-                          <a:ea typeface="Calibri" pitchFamily="34" charset="-122"/>
-                          <a:cs typeface="Calibri" pitchFamily="34" charset="-120"/>
-                        </a:rPr>
-                        <a:t>36.4% / 47.6%</a:t>
-                      </a:r>
-                      <a:endParaRPr lang="en-US" sz="1050" dirty="0">
-                        <a:latin typeface="Calibri" charset="0"/>
-                        <a:ea typeface="Calibri" charset="0"/>
-                        <a:cs typeface="Calibri" charset="0"/>
-                      </a:endParaRPr>
-                    </a:p>
-                  </a:txBody>
-                  <a:tcPr marL="91440" marR="91440" marT="45720" marB="45720" anchor="ctr">
-                    <a:lnL w="9525" cap="flat" cmpd="sng" algn="ctr">
-                      <a:solidFill>
-                        <a:srgbClr val="E4E9EF"/>
-                      </a:solidFill>
-                      <a:prstDash val="solid"/>
-                      <a:round/>
-                      <a:headEnd type="none" w="med" len="med"/>
-                      <a:tailEnd type="none" w="med" len="med"/>
-                    </a:lnL>
-                    <a:lnR w="9525" cap="flat" cmpd="sng" algn="ctr">
-                      <a:solidFill>
-                        <a:srgbClr val="E4E9EF"/>
-                      </a:solidFill>
-                      <a:prstDash val="solid"/>
-                      <a:round/>
-                      <a:headEnd type="none" w="med" len="med"/>
-                      <a:tailEnd type="none" w="med" len="med"/>
-                    </a:lnR>
-                    <a:lnT w="9525" cap="flat" cmpd="sng" algn="ctr">
-                      <a:solidFill>
-                        <a:srgbClr val="E4E9EF"/>
-                      </a:solidFill>
-                      <a:prstDash val="solid"/>
-                      <a:round/>
-                      <a:headEnd type="none" w="med" len="med"/>
-                      <a:tailEnd type="none" w="med" len="med"/>
-                    </a:lnT>
-                    <a:lnB w="9525" cap="flat" cmpd="sng" algn="ctr">
-                      <a:solidFill>
-                        <a:srgbClr val="E4E9EF"/>
-                      </a:solidFill>
-                      <a:prstDash val="solid"/>
-                      <a:round/>
-                      <a:headEnd type="none" w="med" len="med"/>
-                      <a:tailEnd type="none" w="med" len="med"/>
-                    </a:lnB>
-                    <a:solidFill>
-                      <a:srgbClr val="FFFFFF"/>
-                    </a:solidFill>
-                  </a:tcPr>
-                </a:tc>
-                <a:tc>
-                  <a:txBody>
-                    <a:bodyPr/>
-                    <a:lstStyle/>
-                    <a:p>
-                      <a:pPr algn="ctr" indent="0" marL="0">
-                        <a:buNone/>
-                      </a:pPr>
-                      <a:r>
-                        <a:rPr lang="en-US" sz="1050" b="1" dirty="0">
-                          <a:solidFill>
-                            <a:srgbClr val="1E7A46"/>
-                          </a:solidFill>
-                          <a:latin typeface="Calibri" pitchFamily="34" charset="0"/>
-                          <a:ea typeface="Calibri" pitchFamily="34" charset="-122"/>
-                          <a:cs typeface="Calibri" pitchFamily="34" charset="-120"/>
-                        </a:rPr>
-                        <a:t>close</a:t>
-                      </a:r>
-                      <a:endParaRPr lang="en-US" sz="1050" dirty="0">
-                        <a:latin typeface="Calibri" charset="0"/>
-                        <a:ea typeface="Calibri" charset="0"/>
-                        <a:cs typeface="Calibri" charset="0"/>
-                      </a:endParaRPr>
-                    </a:p>
-                  </a:txBody>
-                  <a:tcPr marL="91440" marR="91440" marT="45720" marB="45720" anchor="ctr">
-                    <a:lnL w="9525" cap="flat" cmpd="sng" algn="ctr">
-                      <a:solidFill>
-                        <a:srgbClr val="E4E9EF"/>
-                      </a:solidFill>
-                      <a:prstDash val="solid"/>
-                      <a:round/>
-                      <a:headEnd type="none" w="med" len="med"/>
-                      <a:tailEnd type="none" w="med" len="med"/>
-                    </a:lnL>
-                    <a:lnR w="9525" cap="flat" cmpd="sng" algn="ctr">
-                      <a:solidFill>
-                        <a:srgbClr val="E4E9EF"/>
-                      </a:solidFill>
-                      <a:prstDash val="solid"/>
-                      <a:round/>
-                      <a:headEnd type="none" w="med" len="med"/>
-                      <a:tailEnd type="none" w="med" len="med"/>
-                    </a:lnR>
-                    <a:lnT w="9525" cap="flat" cmpd="sng" algn="ctr">
-                      <a:solidFill>
-                        <a:srgbClr val="E4E9EF"/>
-                      </a:solidFill>
-                      <a:prstDash val="solid"/>
-                      <a:round/>
-                      <a:headEnd type="none" w="med" len="med"/>
-                      <a:tailEnd type="none" w="med" len="med"/>
-                    </a:lnT>
-                    <a:lnB w="9525" cap="flat" cmpd="sng" algn="ctr">
-                      <a:solidFill>
-                        <a:srgbClr val="E4E9EF"/>
-                      </a:solidFill>
-                      <a:prstDash val="solid"/>
-                      <a:round/>
-                      <a:headEnd type="none" w="med" len="med"/>
-                      <a:tailEnd type="none" w="med" len="med"/>
-                    </a:lnB>
-                    <a:solidFill>
-                      <a:srgbClr val="FFFFFF"/>
-                    </a:solidFill>
-                  </a:tcPr>
-                </a:tc>
-              </a:tr>
-              <a:tr h="310896">
-                <a:tc>
-                  <a:txBody>
-                    <a:bodyPr/>
-                    <a:lstStyle/>
-                    <a:p>
-                      <a:pPr indent="0" marL="0">
-                        <a:buNone/>
-                      </a:pPr>
-                      <a:r>
-                        <a:rPr lang="en-US" sz="1050" dirty="0">
-                          <a:solidFill>
-                            <a:srgbClr val="1C2B3A"/>
-                          </a:solidFill>
-                          <a:latin typeface="Calibri" pitchFamily="34" charset="0"/>
-                          <a:ea typeface="Calibri" pitchFamily="34" charset="-122"/>
-                          <a:cs typeface="Calibri" pitchFamily="34" charset="-120"/>
-                        </a:rPr>
-                        <a:t>Brown projected with LeBron</a:t>
-                      </a:r>
-                      <a:endParaRPr lang="en-US" sz="1050" dirty="0">
-                        <a:latin typeface="Calibri" charset="0"/>
-                        <a:ea typeface="Calibri" charset="0"/>
-                        <a:cs typeface="Calibri" charset="0"/>
-                      </a:endParaRPr>
-                    </a:p>
-                  </a:txBody>
-                  <a:tcPr marL="91440" marR="91440" marT="45720" marB="45720" anchor="ctr">
-                    <a:lnL w="9525" cap="flat" cmpd="sng" algn="ctr">
-                      <a:solidFill>
-                        <a:srgbClr val="E4E9EF"/>
-                      </a:solidFill>
-                      <a:prstDash val="solid"/>
-                      <a:round/>
-                      <a:headEnd type="none" w="med" len="med"/>
-                      <a:tailEnd type="none" w="med" len="med"/>
-                    </a:lnL>
-                    <a:lnR w="9525" cap="flat" cmpd="sng" algn="ctr">
-                      <a:solidFill>
-                        <a:srgbClr val="E4E9EF"/>
-                      </a:solidFill>
-                      <a:prstDash val="solid"/>
-                      <a:round/>
-                      <a:headEnd type="none" w="med" len="med"/>
-                      <a:tailEnd type="none" w="med" len="med"/>
-                    </a:lnR>
-                    <a:lnT w="9525" cap="flat" cmpd="sng" algn="ctr">
-                      <a:solidFill>
-                        <a:srgbClr val="E4E9EF"/>
-                      </a:solidFill>
-                      <a:prstDash val="solid"/>
-                      <a:round/>
-                      <a:headEnd type="none" w="med" len="med"/>
-                      <a:tailEnd type="none" w="med" len="med"/>
-                    </a:lnT>
-                    <a:lnB w="9525" cap="flat" cmpd="sng" algn="ctr">
-                      <a:solidFill>
-                        <a:srgbClr val="E4E9EF"/>
-                      </a:solidFill>
-                      <a:prstDash val="solid"/>
-                      <a:round/>
-                      <a:headEnd type="none" w="med" len="med"/>
-                      <a:tailEnd type="none" w="med" len="med"/>
-                    </a:lnB>
-                    <a:solidFill>
-                      <a:srgbClr val="FFFFFF"/>
-                    </a:solidFill>
-                  </a:tcPr>
-                </a:tc>
-                <a:tc>
-                  <a:txBody>
-                    <a:bodyPr/>
-                    <a:lstStyle/>
-                    <a:p>
-                      <a:pPr algn="ctr" indent="0" marL="0">
-                        <a:buNone/>
-                      </a:pPr>
-                      <a:r>
-                        <a:rPr lang="en-US" sz="1050" dirty="0">
-                          <a:solidFill>
-                            <a:srgbClr val="1C2B3A"/>
-                          </a:solidFill>
-                          <a:latin typeface="Calibri" pitchFamily="34" charset="0"/>
-                          <a:ea typeface="Calibri" pitchFamily="34" charset="-122"/>
-                          <a:cs typeface="Calibri" pitchFamily="34" charset="-120"/>
-                        </a:rPr>
-                        <a:t>48%</a:t>
-                      </a:r>
-                      <a:endParaRPr lang="en-US" sz="1050" dirty="0">
-                        <a:latin typeface="Calibri" charset="0"/>
-                        <a:ea typeface="Calibri" charset="0"/>
-                        <a:cs typeface="Calibri" charset="0"/>
-                      </a:endParaRPr>
-                    </a:p>
-                  </a:txBody>
-                  <a:tcPr marL="91440" marR="91440" marT="45720" marB="45720" anchor="ctr">
-                    <a:lnL w="9525" cap="flat" cmpd="sng" algn="ctr">
-                      <a:solidFill>
-                        <a:srgbClr val="E4E9EF"/>
-                      </a:solidFill>
-                      <a:prstDash val="solid"/>
-                      <a:round/>
-                      <a:headEnd type="none" w="med" len="med"/>
-                      <a:tailEnd type="none" w="med" len="med"/>
-                    </a:lnL>
-                    <a:lnR w="9525" cap="flat" cmpd="sng" algn="ctr">
-                      <a:solidFill>
-                        <a:srgbClr val="E4E9EF"/>
-                      </a:solidFill>
-                      <a:prstDash val="solid"/>
-                      <a:round/>
-                      <a:headEnd type="none" w="med" len="med"/>
-                      <a:tailEnd type="none" w="med" len="med"/>
-                    </a:lnR>
-                    <a:lnT w="9525" cap="flat" cmpd="sng" algn="ctr">
-                      <a:solidFill>
-                        <a:srgbClr val="E4E9EF"/>
-                      </a:solidFill>
-                      <a:prstDash val="solid"/>
-                      <a:round/>
-                      <a:headEnd type="none" w="med" len="med"/>
-                      <a:tailEnd type="none" w="med" len="med"/>
-                    </a:lnT>
-                    <a:lnB w="9525" cap="flat" cmpd="sng" algn="ctr">
-                      <a:solidFill>
-                        <a:srgbClr val="E4E9EF"/>
-                      </a:solidFill>
-                      <a:prstDash val="solid"/>
-                      <a:round/>
-                      <a:headEnd type="none" w="med" len="med"/>
-                      <a:tailEnd type="none" w="med" len="med"/>
-                    </a:lnB>
-                    <a:solidFill>
-                      <a:srgbClr val="FFFFFF"/>
-                    </a:solidFill>
-                  </a:tcPr>
-                </a:tc>
-                <a:tc>
-                  <a:txBody>
-                    <a:bodyPr/>
-                    <a:lstStyle/>
-                    <a:p>
-                      <a:pPr algn="ctr" indent="0" marL="0">
-                        <a:buNone/>
-                      </a:pPr>
-                      <a:r>
-                        <a:rPr lang="en-US" sz="1050" dirty="0">
-                          <a:solidFill>
-                            <a:srgbClr val="1C2B3A"/>
-                          </a:solidFill>
-                          <a:latin typeface="Calibri" pitchFamily="34" charset="0"/>
-                          <a:ea typeface="Calibri" pitchFamily="34" charset="-122"/>
-                          <a:cs typeface="Calibri" pitchFamily="34" charset="-120"/>
-                        </a:rPr>
-                        <a:t>51.6%</a:t>
-                      </a:r>
-                      <a:endParaRPr lang="en-US" sz="1050" dirty="0">
-                        <a:latin typeface="Calibri" charset="0"/>
-                        <a:ea typeface="Calibri" charset="0"/>
-                        <a:cs typeface="Calibri" charset="0"/>
-                      </a:endParaRPr>
-                    </a:p>
-                  </a:txBody>
-                  <a:tcPr marL="91440" marR="91440" marT="45720" marB="45720" anchor="ctr">
-                    <a:lnL w="9525" cap="flat" cmpd="sng" algn="ctr">
-                      <a:solidFill>
-                        <a:srgbClr val="E4E9EF"/>
-                      </a:solidFill>
-                      <a:prstDash val="solid"/>
-                      <a:round/>
-                      <a:headEnd type="none" w="med" len="med"/>
-                      <a:tailEnd type="none" w="med" len="med"/>
-                    </a:lnL>
-                    <a:lnR w="9525" cap="flat" cmpd="sng" algn="ctr">
-                      <a:solidFill>
-                        <a:srgbClr val="E4E9EF"/>
-                      </a:solidFill>
-                      <a:prstDash val="solid"/>
-                      <a:round/>
-                      <a:headEnd type="none" w="med" len="med"/>
-                      <a:tailEnd type="none" w="med" len="med"/>
-                    </a:lnR>
-                    <a:lnT w="9525" cap="flat" cmpd="sng" algn="ctr">
-                      <a:solidFill>
-                        <a:srgbClr val="E4E9EF"/>
-                      </a:solidFill>
-                      <a:prstDash val="solid"/>
-                      <a:round/>
-                      <a:headEnd type="none" w="med" len="med"/>
-                      <a:tailEnd type="none" w="med" len="med"/>
-                    </a:lnT>
-                    <a:lnB w="9525" cap="flat" cmpd="sng" algn="ctr">
-                      <a:solidFill>
-                        <a:srgbClr val="E4E9EF"/>
-                      </a:solidFill>
-                      <a:prstDash val="solid"/>
-                      <a:round/>
-                      <a:headEnd type="none" w="med" len="med"/>
-                      <a:tailEnd type="none" w="med" len="med"/>
-                    </a:lnB>
-                    <a:solidFill>
-                      <a:srgbClr val="FFFFFF"/>
-                    </a:solidFill>
-                  </a:tcPr>
-                </a:tc>
-                <a:tc>
-                  <a:txBody>
-                    <a:bodyPr/>
-                    <a:lstStyle/>
-                    <a:p>
-                      <a:pPr algn="ctr" indent="0" marL="0">
-                        <a:buNone/>
-                      </a:pPr>
-                      <a:r>
-                        <a:rPr lang="en-US" sz="1050" b="1" dirty="0">
-                          <a:solidFill>
-                            <a:srgbClr val="1E7A46"/>
-                          </a:solidFill>
-                          <a:latin typeface="Calibri" pitchFamily="34" charset="0"/>
-                          <a:ea typeface="Calibri" pitchFamily="34" charset="-122"/>
-                          <a:cs typeface="Calibri" pitchFamily="34" charset="-120"/>
-                        </a:rPr>
-                        <a:t>close</a:t>
-                      </a:r>
-                      <a:endParaRPr lang="en-US" sz="1050" dirty="0">
-                        <a:latin typeface="Calibri" charset="0"/>
-                        <a:ea typeface="Calibri" charset="0"/>
-                        <a:cs typeface="Calibri" charset="0"/>
-                      </a:endParaRPr>
-                    </a:p>
-                  </a:txBody>
-                  <a:tcPr marL="91440" marR="91440" marT="45720" marB="45720" anchor="ctr">
-                    <a:lnL w="9525" cap="flat" cmpd="sng" algn="ctr">
-                      <a:solidFill>
-                        <a:srgbClr val="E4E9EF"/>
-                      </a:solidFill>
-                      <a:prstDash val="solid"/>
-                      <a:round/>
-                      <a:headEnd type="none" w="med" len="med"/>
-                      <a:tailEnd type="none" w="med" len="med"/>
-                    </a:lnL>
-                    <a:lnR w="9525" cap="flat" cmpd="sng" algn="ctr">
-                      <a:solidFill>
-                        <a:srgbClr val="E4E9EF"/>
-                      </a:solidFill>
-                      <a:prstDash val="solid"/>
-                      <a:round/>
-                      <a:headEnd type="none" w="med" len="med"/>
-                      <a:tailEnd type="none" w="med" len="med"/>
-                    </a:lnR>
-                    <a:lnT w="9525" cap="flat" cmpd="sng" algn="ctr">
-                      <a:solidFill>
-                        <a:srgbClr val="E4E9EF"/>
-                      </a:solidFill>
-                      <a:prstDash val="solid"/>
-                      <a:round/>
-                      <a:headEnd type="none" w="med" len="med"/>
-                      <a:tailEnd type="none" w="med" len="med"/>
-                    </a:lnT>
-                    <a:lnB w="9525" cap="flat" cmpd="sng" algn="ctr">
-                      <a:solidFill>
-                        <a:srgbClr val="E4E9EF"/>
-                      </a:solidFill>
-                      <a:prstDash val="solid"/>
-                      <a:round/>
-                      <a:headEnd type="none" w="med" len="med"/>
-                      <a:tailEnd type="none" w="med" len="med"/>
-                    </a:lnB>
-                    <a:solidFill>
-                      <a:srgbClr val="FFFFFF"/>
-                    </a:solidFill>
-                  </a:tcPr>
-                </a:tc>
-              </a:tr>
-              <a:tr h="310896">
-                <a:tc>
-                  <a:txBody>
-                    <a:bodyPr/>
-                    <a:lstStyle/>
-                    <a:p>
-                      <a:pPr indent="0" marL="0">
-                        <a:buNone/>
-                      </a:pPr>
-                      <a:r>
-                        <a:rPr lang="en-US" sz="1050" dirty="0">
-                          <a:solidFill>
-                            <a:srgbClr val="1C2B3A"/>
-                          </a:solidFill>
-                          <a:latin typeface="Calibri" pitchFamily="34" charset="0"/>
-                          <a:ea typeface="Calibri" pitchFamily="34" charset="-122"/>
-                          <a:cs typeface="Calibri" pitchFamily="34" charset="-120"/>
-                        </a:rPr>
-                        <a:t>LeBron usage / TS, 2025-26</a:t>
-                      </a:r>
-                      <a:endParaRPr lang="en-US" sz="1050" dirty="0">
-                        <a:latin typeface="Calibri" charset="0"/>
-                        <a:ea typeface="Calibri" charset="0"/>
-                        <a:cs typeface="Calibri" charset="0"/>
-                      </a:endParaRPr>
-                    </a:p>
-                  </a:txBody>
-                  <a:tcPr marL="91440" marR="91440" marT="45720" marB="45720" anchor="ctr">
-                    <a:lnL w="9525" cap="flat" cmpd="sng" algn="ctr">
-                      <a:solidFill>
-                        <a:srgbClr val="E4E9EF"/>
-                      </a:solidFill>
-                      <a:prstDash val="solid"/>
-                      <a:round/>
-                      <a:headEnd type="none" w="med" len="med"/>
-                      <a:tailEnd type="none" w="med" len="med"/>
-                    </a:lnL>
-                    <a:lnR w="9525" cap="flat" cmpd="sng" algn="ctr">
-                      <a:solidFill>
-                        <a:srgbClr val="E4E9EF"/>
-                      </a:solidFill>
-                      <a:prstDash val="solid"/>
-                      <a:round/>
-                      <a:headEnd type="none" w="med" len="med"/>
-                      <a:tailEnd type="none" w="med" len="med"/>
-                    </a:lnR>
-                    <a:lnT w="9525" cap="flat" cmpd="sng" algn="ctr">
-                      <a:solidFill>
-                        <a:srgbClr val="E4E9EF"/>
-                      </a:solidFill>
-                      <a:prstDash val="solid"/>
-                      <a:round/>
-                      <a:headEnd type="none" w="med" len="med"/>
-                      <a:tailEnd type="none" w="med" len="med"/>
-                    </a:lnT>
-                    <a:lnB w="9525" cap="flat" cmpd="sng" algn="ctr">
-                      <a:solidFill>
-                        <a:srgbClr val="E4E9EF"/>
-                      </a:solidFill>
-                      <a:prstDash val="solid"/>
-                      <a:round/>
-                      <a:headEnd type="none" w="med" len="med"/>
-                      <a:tailEnd type="none" w="med" len="med"/>
-                    </a:lnB>
-                    <a:solidFill>
-                      <a:srgbClr val="FFFFFF"/>
-                    </a:solidFill>
-                  </a:tcPr>
-                </a:tc>
-                <a:tc>
-                  <a:txBody>
-                    <a:bodyPr/>
-                    <a:lstStyle/>
-                    <a:p>
-                      <a:pPr algn="ctr" indent="0" marL="0">
-                        <a:buNone/>
-                      </a:pPr>
-                      <a:r>
-                        <a:rPr lang="en-US" sz="1050" dirty="0">
-                          <a:solidFill>
-                            <a:srgbClr val="1C2B3A"/>
-                          </a:solidFill>
-                          <a:latin typeface="Calibri" pitchFamily="34" charset="0"/>
-                          <a:ea typeface="Calibri" pitchFamily="34" charset="-122"/>
-                          <a:cs typeface="Calibri" pitchFamily="34" charset="-120"/>
-                        </a:rPr>
-                        <a:t>27.2% / .594</a:t>
-                      </a:r>
-                      <a:endParaRPr lang="en-US" sz="1050" dirty="0">
-                        <a:latin typeface="Calibri" charset="0"/>
-                        <a:ea typeface="Calibri" charset="0"/>
-                        <a:cs typeface="Calibri" charset="0"/>
-                      </a:endParaRPr>
-                    </a:p>
-                  </a:txBody>
-                  <a:tcPr marL="91440" marR="91440" marT="45720" marB="45720" anchor="ctr">
-                    <a:lnL w="9525" cap="flat" cmpd="sng" algn="ctr">
-                      <a:solidFill>
-                        <a:srgbClr val="E4E9EF"/>
-                      </a:solidFill>
-                      <a:prstDash val="solid"/>
-                      <a:round/>
-                      <a:headEnd type="none" w="med" len="med"/>
-                      <a:tailEnd type="none" w="med" len="med"/>
-                    </a:lnL>
-                    <a:lnR w="9525" cap="flat" cmpd="sng" algn="ctr">
-                      <a:solidFill>
-                        <a:srgbClr val="E4E9EF"/>
-                      </a:solidFill>
-                      <a:prstDash val="solid"/>
-                      <a:round/>
-                      <a:headEnd type="none" w="med" len="med"/>
-                      <a:tailEnd type="none" w="med" len="med"/>
-                    </a:lnR>
-                    <a:lnT w="9525" cap="flat" cmpd="sng" algn="ctr">
-                      <a:solidFill>
-                        <a:srgbClr val="E4E9EF"/>
-                      </a:solidFill>
-                      <a:prstDash val="solid"/>
-                      <a:round/>
-                      <a:headEnd type="none" w="med" len="med"/>
-                      <a:tailEnd type="none" w="med" len="med"/>
-                    </a:lnT>
-                    <a:lnB w="9525" cap="flat" cmpd="sng" algn="ctr">
-                      <a:solidFill>
-                        <a:srgbClr val="E4E9EF"/>
-                      </a:solidFill>
-                      <a:prstDash val="solid"/>
-                      <a:round/>
-                      <a:headEnd type="none" w="med" len="med"/>
-                      <a:tailEnd type="none" w="med" len="med"/>
-                    </a:lnB>
-                    <a:solidFill>
-                      <a:srgbClr val="FFFFFF"/>
-                    </a:solidFill>
-                  </a:tcPr>
-                </a:tc>
-                <a:tc>
-                  <a:txBody>
-                    <a:bodyPr/>
-                    <a:lstStyle/>
-                    <a:p>
-                      <a:pPr algn="ctr" indent="0" marL="0">
-                        <a:buNone/>
-                      </a:pPr>
-                      <a:r>
-                        <a:rPr lang="en-US" sz="1050" dirty="0">
-                          <a:solidFill>
-                            <a:srgbClr val="1C2B3A"/>
-                          </a:solidFill>
-                          <a:latin typeface="Calibri" pitchFamily="34" charset="0"/>
-                          <a:ea typeface="Calibri" pitchFamily="34" charset="-122"/>
-                          <a:cs typeface="Calibri" pitchFamily="34" charset="-120"/>
-                        </a:rPr>
-                        <a:t>27.2% / .594</a:t>
-                      </a:r>
-                      <a:endParaRPr lang="en-US" sz="1050" dirty="0">
-                        <a:latin typeface="Calibri" charset="0"/>
-                        <a:ea typeface="Calibri" charset="0"/>
-                        <a:cs typeface="Calibri" charset="0"/>
-                      </a:endParaRPr>
-                    </a:p>
-                  </a:txBody>
-                  <a:tcPr marL="91440" marR="91440" marT="45720" marB="45720" anchor="ctr">
-                    <a:lnL w="9525" cap="flat" cmpd="sng" algn="ctr">
-                      <a:solidFill>
-                        <a:srgbClr val="E4E9EF"/>
-                      </a:solidFill>
-                      <a:prstDash val="solid"/>
-                      <a:round/>
-                      <a:headEnd type="none" w="med" len="med"/>
-                      <a:tailEnd type="none" w="med" len="med"/>
-                    </a:lnL>
-                    <a:lnR w="9525" cap="flat" cmpd="sng" algn="ctr">
-                      <a:solidFill>
-                        <a:srgbClr val="E4E9EF"/>
-                      </a:solidFill>
-                      <a:prstDash val="solid"/>
-                      <a:round/>
-                      <a:headEnd type="none" w="med" len="med"/>
-                      <a:tailEnd type="none" w="med" len="med"/>
-                    </a:lnR>
-                    <a:lnT w="9525" cap="flat" cmpd="sng" algn="ctr">
-                      <a:solidFill>
-                        <a:srgbClr val="E4E9EF"/>
-                      </a:solidFill>
-                      <a:prstDash val="solid"/>
-                      <a:round/>
-                      <a:headEnd type="none" w="med" len="med"/>
-                      <a:tailEnd type="none" w="med" len="med"/>
-                    </a:lnT>
-                    <a:lnB w="9525" cap="flat" cmpd="sng" algn="ctr">
-                      <a:solidFill>
-                        <a:srgbClr val="E4E9EF"/>
-                      </a:solidFill>
-                      <a:prstDash val="solid"/>
-                      <a:round/>
-                      <a:headEnd type="none" w="med" len="med"/>
-                      <a:tailEnd type="none" w="med" len="med"/>
-                    </a:lnB>
-                    <a:solidFill>
-                      <a:srgbClr val="FFFFFF"/>
-                    </a:solidFill>
-                  </a:tcPr>
-                </a:tc>
-                <a:tc>
-                  <a:txBody>
-                    <a:bodyPr/>
-                    <a:lstStyle/>
-                    <a:p>
-                      <a:pPr algn="ctr" indent="0" marL="0">
-                        <a:buNone/>
-                      </a:pPr>
-                      <a:r>
-                        <a:rPr lang="en-US" sz="1050" b="1" dirty="0">
-                          <a:solidFill>
-                            <a:srgbClr val="1E7A46"/>
-                          </a:solidFill>
-                          <a:latin typeface="Calibri" pitchFamily="34" charset="0"/>
-                          <a:ea typeface="Calibri" pitchFamily="34" charset="-122"/>
-                          <a:cs typeface="Calibri" pitchFamily="34" charset="-120"/>
-                        </a:rPr>
-                        <a:t>exact</a:t>
-                      </a:r>
-                      <a:endParaRPr lang="en-US" sz="1050" dirty="0">
-                        <a:latin typeface="Calibri" charset="0"/>
-                        <a:ea typeface="Calibri" charset="0"/>
-                        <a:cs typeface="Calibri" charset="0"/>
-                      </a:endParaRPr>
-                    </a:p>
-                  </a:txBody>
-                  <a:tcPr marL="91440" marR="91440" marT="45720" marB="45720" anchor="ctr">
-                    <a:lnL w="9525" cap="flat" cmpd="sng" algn="ctr">
-                      <a:solidFill>
-                        <a:srgbClr val="E4E9EF"/>
-                      </a:solidFill>
-                      <a:prstDash val="solid"/>
-                      <a:round/>
-                      <a:headEnd type="none" w="med" len="med"/>
-                      <a:tailEnd type="none" w="med" len="med"/>
-                    </a:lnL>
-                    <a:lnR w="9525" cap="flat" cmpd="sng" algn="ctr">
-                      <a:solidFill>
-                        <a:srgbClr val="E4E9EF"/>
-                      </a:solidFill>
-                      <a:prstDash val="solid"/>
-                      <a:round/>
-                      <a:headEnd type="none" w="med" len="med"/>
-                      <a:tailEnd type="none" w="med" len="med"/>
-                    </a:lnR>
-                    <a:lnT w="9525" cap="flat" cmpd="sng" algn="ctr">
-                      <a:solidFill>
-                        <a:srgbClr val="E4E9EF"/>
-                      </a:solidFill>
-                      <a:prstDash val="solid"/>
-                      <a:round/>
-                      <a:headEnd type="none" w="med" len="med"/>
-                      <a:tailEnd type="none" w="med" len="med"/>
-                    </a:lnT>
-                    <a:lnB w="9525" cap="flat" cmpd="sng" algn="ctr">
-                      <a:solidFill>
-                        <a:srgbClr val="E4E9EF"/>
-                      </a:solidFill>
-                      <a:prstDash val="solid"/>
-                      <a:round/>
-                      <a:headEnd type="none" w="med" len="med"/>
-                      <a:tailEnd type="none" w="med" len="med"/>
-                    </a:lnB>
-                    <a:solidFill>
-                      <a:srgbClr val="FFFFFF"/>
-                    </a:solidFill>
-                  </a:tcPr>
-                </a:tc>
-              </a:tr>
-              <a:tr h="310896">
-                <a:tc>
-                  <a:txBody>
-                    <a:bodyPr/>
-                    <a:lstStyle/>
-                    <a:p>
-                      <a:pPr indent="0" marL="0">
-                        <a:buNone/>
-                      </a:pPr>
-                      <a:r>
-                        <a:rPr lang="en-US" sz="1050" dirty="0">
-                          <a:solidFill>
-                            <a:srgbClr val="1C2B3A"/>
-                          </a:solidFill>
-                          <a:latin typeface="Calibri" pitchFamily="34" charset="0"/>
-                          <a:ea typeface="Calibri" pitchFamily="34" charset="-122"/>
-                          <a:cs typeface="Calibri" pitchFamily="34" charset="-120"/>
-                        </a:rPr>
-                        <a:t>Embiid rim share of makes</a:t>
-                      </a:r>
-                      <a:endParaRPr lang="en-US" sz="1050" dirty="0">
-                        <a:latin typeface="Calibri" charset="0"/>
-                        <a:ea typeface="Calibri" charset="0"/>
-                        <a:cs typeface="Calibri" charset="0"/>
-                      </a:endParaRPr>
-                    </a:p>
-                  </a:txBody>
-                  <a:tcPr marL="91440" marR="91440" marT="45720" marB="45720" anchor="ctr">
-                    <a:lnL w="9525" cap="flat" cmpd="sng" algn="ctr">
-                      <a:solidFill>
-                        <a:srgbClr val="E4E9EF"/>
-                      </a:solidFill>
-                      <a:prstDash val="solid"/>
-                      <a:round/>
-                      <a:headEnd type="none" w="med" len="med"/>
-                      <a:tailEnd type="none" w="med" len="med"/>
-                    </a:lnL>
-                    <a:lnR w="9525" cap="flat" cmpd="sng" algn="ctr">
-                      <a:solidFill>
-                        <a:srgbClr val="E4E9EF"/>
-                      </a:solidFill>
-                      <a:prstDash val="solid"/>
-                      <a:round/>
-                      <a:headEnd type="none" w="med" len="med"/>
-                      <a:tailEnd type="none" w="med" len="med"/>
-                    </a:lnR>
-                    <a:lnT w="9525" cap="flat" cmpd="sng" algn="ctr">
-                      <a:solidFill>
-                        <a:srgbClr val="E4E9EF"/>
-                      </a:solidFill>
-                      <a:prstDash val="solid"/>
-                      <a:round/>
-                      <a:headEnd type="none" w="med" len="med"/>
-                      <a:tailEnd type="none" w="med" len="med"/>
-                    </a:lnT>
-                    <a:lnB w="9525" cap="flat" cmpd="sng" algn="ctr">
-                      <a:solidFill>
-                        <a:srgbClr val="E4E9EF"/>
-                      </a:solidFill>
-                      <a:prstDash val="solid"/>
-                      <a:round/>
-                      <a:headEnd type="none" w="med" len="med"/>
-                      <a:tailEnd type="none" w="med" len="med"/>
-                    </a:lnB>
-                    <a:solidFill>
-                      <a:srgbClr val="FFFFFF"/>
-                    </a:solidFill>
-                  </a:tcPr>
-                </a:tc>
-                <a:tc>
-                  <a:txBody>
-                    <a:bodyPr/>
-                    <a:lstStyle/>
-                    <a:p>
-                      <a:pPr algn="ctr" indent="0" marL="0">
-                        <a:buNone/>
-                      </a:pPr>
-                      <a:r>
-                        <a:rPr lang="en-US" sz="1050" dirty="0">
-                          <a:solidFill>
-                            <a:srgbClr val="1C2B3A"/>
-                          </a:solidFill>
-                          <a:latin typeface="Calibri" pitchFamily="34" charset="0"/>
-                          <a:ea typeface="Calibri" pitchFamily="34" charset="-122"/>
-                          <a:cs typeface="Calibri" pitchFamily="34" charset="-120"/>
-                        </a:rPr>
-                        <a:t>37%</a:t>
-                      </a:r>
-                      <a:endParaRPr lang="en-US" sz="1050" dirty="0">
-                        <a:latin typeface="Calibri" charset="0"/>
-                        <a:ea typeface="Calibri" charset="0"/>
-                        <a:cs typeface="Calibri" charset="0"/>
-                      </a:endParaRPr>
-                    </a:p>
-                  </a:txBody>
-                  <a:tcPr marL="91440" marR="91440" marT="45720" marB="45720" anchor="ctr">
-                    <a:lnL w="9525" cap="flat" cmpd="sng" algn="ctr">
-                      <a:solidFill>
-                        <a:srgbClr val="E4E9EF"/>
-                      </a:solidFill>
-                      <a:prstDash val="solid"/>
-                      <a:round/>
-                      <a:headEnd type="none" w="med" len="med"/>
-                      <a:tailEnd type="none" w="med" len="med"/>
-                    </a:lnL>
-                    <a:lnR w="9525" cap="flat" cmpd="sng" algn="ctr">
-                      <a:solidFill>
-                        <a:srgbClr val="E4E9EF"/>
-                      </a:solidFill>
-                      <a:prstDash val="solid"/>
-                      <a:round/>
-                      <a:headEnd type="none" w="med" len="med"/>
-                      <a:tailEnd type="none" w="med" len="med"/>
-                    </a:lnR>
-                    <a:lnT w="9525" cap="flat" cmpd="sng" algn="ctr">
-                      <a:solidFill>
-                        <a:srgbClr val="E4E9EF"/>
-                      </a:solidFill>
-                      <a:prstDash val="solid"/>
-                      <a:round/>
-                      <a:headEnd type="none" w="med" len="med"/>
-                      <a:tailEnd type="none" w="med" len="med"/>
-                    </a:lnT>
-                    <a:lnB w="9525" cap="flat" cmpd="sng" algn="ctr">
-                      <a:solidFill>
-                        <a:srgbClr val="E4E9EF"/>
-                      </a:solidFill>
-                      <a:prstDash val="solid"/>
-                      <a:round/>
-                      <a:headEnd type="none" w="med" len="med"/>
-                      <a:tailEnd type="none" w="med" len="med"/>
-                    </a:lnB>
-                    <a:solidFill>
-                      <a:srgbClr val="FFFFFF"/>
-                    </a:solidFill>
-                  </a:tcPr>
-                </a:tc>
-                <a:tc>
-                  <a:txBody>
-                    <a:bodyPr/>
-                    <a:lstStyle/>
-                    <a:p>
-                      <a:pPr algn="ctr" indent="0" marL="0">
-                        <a:buNone/>
-                      </a:pPr>
-                      <a:r>
-                        <a:rPr lang="en-US" sz="1050" dirty="0">
-                          <a:solidFill>
-                            <a:srgbClr val="1C2B3A"/>
-                          </a:solidFill>
-                          <a:latin typeface="Calibri" pitchFamily="34" charset="0"/>
-                          <a:ea typeface="Calibri" pitchFamily="34" charset="-122"/>
-                          <a:cs typeface="Calibri" pitchFamily="34" charset="-120"/>
-                        </a:rPr>
-                        <a:t>34.9% (pbpstats)</a:t>
-                      </a:r>
-                      <a:endParaRPr lang="en-US" sz="1050" dirty="0">
-                        <a:latin typeface="Calibri" charset="0"/>
-                        <a:ea typeface="Calibri" charset="0"/>
-                        <a:cs typeface="Calibri" charset="0"/>
-                      </a:endParaRPr>
-                    </a:p>
-                  </a:txBody>
-                  <a:tcPr marL="91440" marR="91440" marT="45720" marB="45720" anchor="ctr">
-                    <a:lnL w="9525" cap="flat" cmpd="sng" algn="ctr">
-                      <a:solidFill>
-                        <a:srgbClr val="E4E9EF"/>
-                      </a:solidFill>
-                      <a:prstDash val="solid"/>
-                      <a:round/>
-                      <a:headEnd type="none" w="med" len="med"/>
-                      <a:tailEnd type="none" w="med" len="med"/>
-                    </a:lnL>
-                    <a:lnR w="9525" cap="flat" cmpd="sng" algn="ctr">
-                      <a:solidFill>
-                        <a:srgbClr val="E4E9EF"/>
-                      </a:solidFill>
-                      <a:prstDash val="solid"/>
-                      <a:round/>
-                      <a:headEnd type="none" w="med" len="med"/>
-                      <a:tailEnd type="none" w="med" len="med"/>
-                    </a:lnR>
-                    <a:lnT w="9525" cap="flat" cmpd="sng" algn="ctr">
-                      <a:solidFill>
-                        <a:srgbClr val="E4E9EF"/>
-                      </a:solidFill>
-                      <a:prstDash val="solid"/>
-                      <a:round/>
-                      <a:headEnd type="none" w="med" len="med"/>
-                      <a:tailEnd type="none" w="med" len="med"/>
-                    </a:lnT>
-                    <a:lnB w="9525" cap="flat" cmpd="sng" algn="ctr">
-                      <a:solidFill>
-                        <a:srgbClr val="E4E9EF"/>
-                      </a:solidFill>
-                      <a:prstDash val="solid"/>
-                      <a:round/>
-                      <a:headEnd type="none" w="med" len="med"/>
-                      <a:tailEnd type="none" w="med" len="med"/>
-                    </a:lnB>
-                    <a:solidFill>
-                      <a:srgbClr val="FFFFFF"/>
-                    </a:solidFill>
-                  </a:tcPr>
-                </a:tc>
-                <a:tc>
-                  <a:txBody>
-                    <a:bodyPr/>
-                    <a:lstStyle/>
-                    <a:p>
-                      <a:pPr algn="ctr" indent="0" marL="0">
-                        <a:buNone/>
-                      </a:pPr>
-                      <a:r>
-                        <a:rPr lang="en-US" sz="1050" b="1" dirty="0">
-                          <a:solidFill>
-                            <a:srgbClr val="B07A00"/>
-                          </a:solidFill>
-                          <a:latin typeface="Calibri" pitchFamily="34" charset="0"/>
-                          <a:ea typeface="Calibri" pitchFamily="34" charset="-122"/>
-                          <a:cs typeface="Calibri" pitchFamily="34" charset="-120"/>
-                        </a:rPr>
-                        <a:t>off ~2</a:t>
-                      </a:r>
-                      <a:endParaRPr lang="en-US" sz="1050" dirty="0">
-                        <a:latin typeface="Calibri" charset="0"/>
-                        <a:ea typeface="Calibri" charset="0"/>
-                        <a:cs typeface="Calibri" charset="0"/>
-                      </a:endParaRPr>
-                    </a:p>
-                  </a:txBody>
-                  <a:tcPr marL="91440" marR="91440" marT="45720" marB="45720" anchor="ctr">
-                    <a:lnL w="9525" cap="flat" cmpd="sng" algn="ctr">
-                      <a:solidFill>
-                        <a:srgbClr val="E4E9EF"/>
-                      </a:solidFill>
-                      <a:prstDash val="solid"/>
-                      <a:round/>
-                      <a:headEnd type="none" w="med" len="med"/>
-                      <a:tailEnd type="none" w="med" len="med"/>
-                    </a:lnL>
-                    <a:lnR w="9525" cap="flat" cmpd="sng" algn="ctr">
-                      <a:solidFill>
-                        <a:srgbClr val="E4E9EF"/>
-                      </a:solidFill>
-                      <a:prstDash val="solid"/>
-                      <a:round/>
-                      <a:headEnd type="none" w="med" len="med"/>
-                      <a:tailEnd type="none" w="med" len="med"/>
-                    </a:lnR>
-                    <a:lnT w="9525" cap="flat" cmpd="sng" algn="ctr">
-                      <a:solidFill>
-                        <a:srgbClr val="E4E9EF"/>
-                      </a:solidFill>
-                      <a:prstDash val="solid"/>
-                      <a:round/>
-                      <a:headEnd type="none" w="med" len="med"/>
-                      <a:tailEnd type="none" w="med" len="med"/>
-                    </a:lnT>
-                    <a:lnB w="9525" cap="flat" cmpd="sng" algn="ctr">
-                      <a:solidFill>
-                        <a:srgbClr val="E4E9EF"/>
-                      </a:solidFill>
-                      <a:prstDash val="solid"/>
-                      <a:round/>
-                      <a:headEnd type="none" w="med" len="med"/>
-                      <a:tailEnd type="none" w="med" len="med"/>
-                    </a:lnB>
-                    <a:solidFill>
-                      <a:srgbClr val="FFFFFF"/>
-                    </a:solidFill>
-                  </a:tcPr>
-                </a:tc>
-              </a:tr>
-              <a:tr h="310896">
-                <a:tc>
-                  <a:txBody>
-                    <a:bodyPr/>
-                    <a:lstStyle/>
-                    <a:p>
-                      <a:pPr indent="0" marL="0">
-                        <a:buNone/>
-                      </a:pPr>
-                      <a:r>
-                        <a:rPr lang="en-US" sz="1050" dirty="0">
-                          <a:solidFill>
-                            <a:srgbClr val="1C2B3A"/>
-                          </a:solidFill>
-                          <a:latin typeface="Calibri" pitchFamily="34" charset="0"/>
-                          <a:ea typeface="Calibri" pitchFamily="34" charset="-122"/>
-                          <a:cs typeface="Calibri" pitchFamily="34" charset="-120"/>
-                        </a:rPr>
-                        <a:t>“52% of LeBron’s 765 assists at rim”</a:t>
-                      </a:r>
-                      <a:endParaRPr lang="en-US" sz="1050" dirty="0">
-                        <a:latin typeface="Calibri" charset="0"/>
-                        <a:ea typeface="Calibri" charset="0"/>
-                        <a:cs typeface="Calibri" charset="0"/>
-                      </a:endParaRPr>
-                    </a:p>
-                  </a:txBody>
-                  <a:tcPr marL="91440" marR="91440" marT="45720" marB="45720" anchor="ctr">
-                    <a:lnL w="9525" cap="flat" cmpd="sng" algn="ctr">
-                      <a:solidFill>
-                        <a:srgbClr val="E4E9EF"/>
-                      </a:solidFill>
-                      <a:prstDash val="solid"/>
-                      <a:round/>
-                      <a:headEnd type="none" w="med" len="med"/>
-                      <a:tailEnd type="none" w="med" len="med"/>
-                    </a:lnL>
-                    <a:lnR w="9525" cap="flat" cmpd="sng" algn="ctr">
-                      <a:solidFill>
-                        <a:srgbClr val="E4E9EF"/>
-                      </a:solidFill>
-                      <a:prstDash val="solid"/>
-                      <a:round/>
-                      <a:headEnd type="none" w="med" len="med"/>
-                      <a:tailEnd type="none" w="med" len="med"/>
-                    </a:lnR>
-                    <a:lnT w="9525" cap="flat" cmpd="sng" algn="ctr">
-                      <a:solidFill>
-                        <a:srgbClr val="E4E9EF"/>
-                      </a:solidFill>
-                      <a:prstDash val="solid"/>
-                      <a:round/>
-                      <a:headEnd type="none" w="med" len="med"/>
-                      <a:tailEnd type="none" w="med" len="med"/>
-                    </a:lnT>
-                    <a:lnB w="9525" cap="flat" cmpd="sng" algn="ctr">
-                      <a:solidFill>
-                        <a:srgbClr val="E4E9EF"/>
-                      </a:solidFill>
-                      <a:prstDash val="solid"/>
-                      <a:round/>
-                      <a:headEnd type="none" w="med" len="med"/>
-                      <a:tailEnd type="none" w="med" len="med"/>
-                    </a:lnB>
-                    <a:solidFill>
-                      <a:srgbClr val="FFFFFF"/>
-                    </a:solidFill>
-                  </a:tcPr>
-                </a:tc>
-                <a:tc>
-                  <a:txBody>
-                    <a:bodyPr/>
-                    <a:lstStyle/>
-                    <a:p>
-                      <a:pPr algn="ctr" indent="0" marL="0">
-                        <a:buNone/>
-                      </a:pPr>
-                      <a:r>
-                        <a:rPr lang="en-US" sz="1050" dirty="0">
-                          <a:solidFill>
-                            <a:srgbClr val="1C2B3A"/>
-                          </a:solidFill>
-                          <a:latin typeface="Calibri" pitchFamily="34" charset="0"/>
-                          <a:ea typeface="Calibri" pitchFamily="34" charset="-122"/>
-                          <a:cs typeface="Calibri" pitchFamily="34" charset="-120"/>
-                        </a:rPr>
-                        <a:t>52% · 765</a:t>
-                      </a:r>
-                      <a:endParaRPr lang="en-US" sz="1050" dirty="0">
-                        <a:latin typeface="Calibri" charset="0"/>
-                        <a:ea typeface="Calibri" charset="0"/>
-                        <a:cs typeface="Calibri" charset="0"/>
-                      </a:endParaRPr>
-                    </a:p>
-                  </a:txBody>
-                  <a:tcPr marL="91440" marR="91440" marT="45720" marB="45720" anchor="ctr">
-                    <a:lnL w="9525" cap="flat" cmpd="sng" algn="ctr">
-                      <a:solidFill>
-                        <a:srgbClr val="E4E9EF"/>
-                      </a:solidFill>
-                      <a:prstDash val="solid"/>
-                      <a:round/>
-                      <a:headEnd type="none" w="med" len="med"/>
-                      <a:tailEnd type="none" w="med" len="med"/>
-                    </a:lnL>
-                    <a:lnR w="9525" cap="flat" cmpd="sng" algn="ctr">
-                      <a:solidFill>
-                        <a:srgbClr val="E4E9EF"/>
-                      </a:solidFill>
-                      <a:prstDash val="solid"/>
-                      <a:round/>
-                      <a:headEnd type="none" w="med" len="med"/>
-                      <a:tailEnd type="none" w="med" len="med"/>
-                    </a:lnR>
-                    <a:lnT w="9525" cap="flat" cmpd="sng" algn="ctr">
-                      <a:solidFill>
-                        <a:srgbClr val="E4E9EF"/>
-                      </a:solidFill>
-                      <a:prstDash val="solid"/>
-                      <a:round/>
-                      <a:headEnd type="none" w="med" len="med"/>
-                      <a:tailEnd type="none" w="med" len="med"/>
-                    </a:lnT>
-                    <a:lnB w="9525" cap="flat" cmpd="sng" algn="ctr">
-                      <a:solidFill>
-                        <a:srgbClr val="E4E9EF"/>
-                      </a:solidFill>
-                      <a:prstDash val="solid"/>
-                      <a:round/>
-                      <a:headEnd type="none" w="med" len="med"/>
-                      <a:tailEnd type="none" w="med" len="med"/>
-                    </a:lnB>
-                    <a:solidFill>
-                      <a:srgbClr val="FFFFFF"/>
-                    </a:solidFill>
-                  </a:tcPr>
-                </a:tc>
-                <a:tc>
-                  <a:txBody>
-                    <a:bodyPr/>
-                    <a:lstStyle/>
-                    <a:p>
-                      <a:pPr algn="ctr" indent="0" marL="0">
-                        <a:buNone/>
-                      </a:pPr>
-                      <a:r>
-                        <a:rPr lang="en-US" sz="1050" dirty="0">
-                          <a:solidFill>
-                            <a:srgbClr val="1C2B3A"/>
-                          </a:solidFill>
-                          <a:latin typeface="Calibri" pitchFamily="34" charset="0"/>
-                          <a:ea typeface="Calibri" pitchFamily="34" charset="-122"/>
-                          <a:cs typeface="Calibri" pitchFamily="34" charset="-120"/>
-                        </a:rPr>
-                        <a:t>42.1% · 432 assists</a:t>
-                      </a:r>
-                      <a:endParaRPr lang="en-US" sz="1050" dirty="0">
-                        <a:latin typeface="Calibri" charset="0"/>
-                        <a:ea typeface="Calibri" charset="0"/>
-                        <a:cs typeface="Calibri" charset="0"/>
-                      </a:endParaRPr>
-                    </a:p>
-                  </a:txBody>
-                  <a:tcPr marL="91440" marR="91440" marT="45720" marB="45720" anchor="ctr">
-                    <a:lnL w="9525" cap="flat" cmpd="sng" algn="ctr">
-                      <a:solidFill>
-                        <a:srgbClr val="E4E9EF"/>
-                      </a:solidFill>
-                      <a:prstDash val="solid"/>
-                      <a:round/>
-                      <a:headEnd type="none" w="med" len="med"/>
-                      <a:tailEnd type="none" w="med" len="med"/>
-                    </a:lnL>
-                    <a:lnR w="9525" cap="flat" cmpd="sng" algn="ctr">
-                      <a:solidFill>
-                        <a:srgbClr val="E4E9EF"/>
-                      </a:solidFill>
-                      <a:prstDash val="solid"/>
-                      <a:round/>
-                      <a:headEnd type="none" w="med" len="med"/>
-                      <a:tailEnd type="none" w="med" len="med"/>
-                    </a:lnR>
-                    <a:lnT w="9525" cap="flat" cmpd="sng" algn="ctr">
-                      <a:solidFill>
-                        <a:srgbClr val="E4E9EF"/>
-                      </a:solidFill>
-                      <a:prstDash val="solid"/>
-                      <a:round/>
-                      <a:headEnd type="none" w="med" len="med"/>
-                      <a:tailEnd type="none" w="med" len="med"/>
-                    </a:lnT>
-                    <a:lnB w="9525" cap="flat" cmpd="sng" algn="ctr">
-                      <a:solidFill>
-                        <a:srgbClr val="E4E9EF"/>
-                      </a:solidFill>
-                      <a:prstDash val="solid"/>
-                      <a:round/>
-                      <a:headEnd type="none" w="med" len="med"/>
-                      <a:tailEnd type="none" w="med" len="med"/>
-                    </a:lnB>
-                    <a:solidFill>
-                      <a:srgbClr val="FFFFFF"/>
-                    </a:solidFill>
-                  </a:tcPr>
-                </a:tc>
-                <a:tc>
-                  <a:txBody>
-                    <a:bodyPr/>
-                    <a:lstStyle/>
-                    <a:p>
-                      <a:pPr algn="ctr" indent="0" marL="0">
-                        <a:buNone/>
-                      </a:pPr>
-                      <a:r>
-                        <a:rPr lang="en-US" sz="1050" b="1" dirty="0">
-                          <a:solidFill>
-                            <a:srgbClr val="C8102E"/>
-                          </a:solidFill>
-                          <a:latin typeface="Calibri" pitchFamily="34" charset="0"/>
-                          <a:ea typeface="Calibri" pitchFamily="34" charset="-122"/>
-                          <a:cs typeface="Calibri" pitchFamily="34" charset="-120"/>
-                        </a:rPr>
-                        <a:t>wrong</a:t>
-                      </a:r>
-                      <a:endParaRPr lang="en-US" sz="1050" dirty="0">
-                        <a:latin typeface="Calibri" charset="0"/>
-                        <a:ea typeface="Calibri" charset="0"/>
-                        <a:cs typeface="Calibri" charset="0"/>
-                      </a:endParaRPr>
-                    </a:p>
-                  </a:txBody>
-                  <a:tcPr marL="91440" marR="91440" marT="45720" marB="45720" anchor="ctr">
-                    <a:lnL w="9525" cap="flat" cmpd="sng" algn="ctr">
-                      <a:solidFill>
-                        <a:srgbClr val="E4E9EF"/>
-                      </a:solidFill>
-                      <a:prstDash val="solid"/>
-                      <a:round/>
-                      <a:headEnd type="none" w="med" len="med"/>
-                      <a:tailEnd type="none" w="med" len="med"/>
-                    </a:lnL>
-                    <a:lnR w="9525" cap="flat" cmpd="sng" algn="ctr">
-                      <a:solidFill>
-                        <a:srgbClr val="E4E9EF"/>
-                      </a:solidFill>
-                      <a:prstDash val="solid"/>
-                      <a:round/>
-                      <a:headEnd type="none" w="med" len="med"/>
-                      <a:tailEnd type="none" w="med" len="med"/>
-                    </a:lnR>
-                    <a:lnT w="9525" cap="flat" cmpd="sng" algn="ctr">
-                      <a:solidFill>
-                        <a:srgbClr val="E4E9EF"/>
-                      </a:solidFill>
-                      <a:prstDash val="solid"/>
-                      <a:round/>
-                      <a:headEnd type="none" w="med" len="med"/>
-                      <a:tailEnd type="none" w="med" len="med"/>
-                    </a:lnT>
-                    <a:lnB w="9525" cap="flat" cmpd="sng" algn="ctr">
-                      <a:solidFill>
-                        <a:srgbClr val="E4E9EF"/>
-                      </a:solidFill>
-                      <a:prstDash val="solid"/>
-                      <a:round/>
-                      <a:headEnd type="none" w="med" len="med"/>
-                      <a:tailEnd type="none" w="med" len="med"/>
-                    </a:lnB>
-                    <a:solidFill>
-                      <a:srgbClr val="FFFFFF"/>
-                    </a:solidFill>
-                  </a:tcPr>
-                </a:tc>
-              </a:tr>
-              <a:tr h="310896">
-                <a:tc>
-                  <a:txBody>
-                    <a:bodyPr/>
-                    <a:lstStyle/>
-                    <a:p>
-                      <a:pPr indent="0" marL="0">
-                        <a:buNone/>
-                      </a:pPr>
-                      <a:r>
-                        <a:rPr lang="en-US" sz="1050" dirty="0">
-                          <a:solidFill>
-                            <a:srgbClr val="1C2B3A"/>
-                          </a:solidFill>
-                          <a:latin typeface="Calibri" pitchFamily="34" charset="0"/>
-                          <a:ea typeface="Calibri" pitchFamily="34" charset="-122"/>
-                          <a:cs typeface="Calibri" pitchFamily="34" charset="-120"/>
-                        </a:rPr>
-                        <a:t>Embiid projected rim share</a:t>
-                      </a:r>
-                      <a:endParaRPr lang="en-US" sz="1050" dirty="0">
-                        <a:latin typeface="Calibri" charset="0"/>
-                        <a:ea typeface="Calibri" charset="0"/>
-                        <a:cs typeface="Calibri" charset="0"/>
-                      </a:endParaRPr>
-                    </a:p>
-                  </a:txBody>
-                  <a:tcPr marL="91440" marR="91440" marT="45720" marB="45720" anchor="ctr">
-                    <a:lnL w="9525" cap="flat" cmpd="sng" algn="ctr">
-                      <a:solidFill>
-                        <a:srgbClr val="E4E9EF"/>
-                      </a:solidFill>
-                      <a:prstDash val="solid"/>
-                      <a:round/>
-                      <a:headEnd type="none" w="med" len="med"/>
-                      <a:tailEnd type="none" w="med" len="med"/>
-                    </a:lnL>
-                    <a:lnR w="9525" cap="flat" cmpd="sng" algn="ctr">
-                      <a:solidFill>
-                        <a:srgbClr val="E4E9EF"/>
-                      </a:solidFill>
-                      <a:prstDash val="solid"/>
-                      <a:round/>
-                      <a:headEnd type="none" w="med" len="med"/>
-                      <a:tailEnd type="none" w="med" len="med"/>
-                    </a:lnR>
-                    <a:lnT w="9525" cap="flat" cmpd="sng" algn="ctr">
-                      <a:solidFill>
-                        <a:srgbClr val="E4E9EF"/>
-                      </a:solidFill>
-                      <a:prstDash val="solid"/>
-                      <a:round/>
-                      <a:headEnd type="none" w="med" len="med"/>
-                      <a:tailEnd type="none" w="med" len="med"/>
-                    </a:lnT>
-                    <a:lnB w="9525" cap="flat" cmpd="sng" algn="ctr">
-                      <a:solidFill>
-                        <a:srgbClr val="E4E9EF"/>
-                      </a:solidFill>
-                      <a:prstDash val="solid"/>
-                      <a:round/>
-                      <a:headEnd type="none" w="med" len="med"/>
-                      <a:tailEnd type="none" w="med" len="med"/>
-                    </a:lnB>
-                    <a:solidFill>
-                      <a:srgbClr val="FFFFFF"/>
-                    </a:solidFill>
-                  </a:tcPr>
-                </a:tc>
-                <a:tc>
-                  <a:txBody>
-                    <a:bodyPr/>
-                    <a:lstStyle/>
-                    <a:p>
-                      <a:pPr algn="ctr" indent="0" marL="0">
-                        <a:buNone/>
-                      </a:pPr>
-                      <a:r>
-                        <a:rPr lang="en-US" sz="1050" dirty="0">
-                          <a:solidFill>
-                            <a:srgbClr val="1C2B3A"/>
-                          </a:solidFill>
-                          <a:latin typeface="Calibri" pitchFamily="34" charset="0"/>
-                          <a:ea typeface="Calibri" pitchFamily="34" charset="-122"/>
-                          <a:cs typeface="Calibri" pitchFamily="34" charset="-120"/>
-                        </a:rPr>
-                        <a:t>42%</a:t>
-                      </a:r>
-                      <a:endParaRPr lang="en-US" sz="1050" dirty="0">
-                        <a:latin typeface="Calibri" charset="0"/>
-                        <a:ea typeface="Calibri" charset="0"/>
-                        <a:cs typeface="Calibri" charset="0"/>
-                      </a:endParaRPr>
-                    </a:p>
-                  </a:txBody>
-                  <a:tcPr marL="91440" marR="91440" marT="45720" marB="45720" anchor="ctr">
-                    <a:lnL w="9525" cap="flat" cmpd="sng" algn="ctr">
-                      <a:solidFill>
-                        <a:srgbClr val="E4E9EF"/>
-                      </a:solidFill>
-                      <a:prstDash val="solid"/>
-                      <a:round/>
-                      <a:headEnd type="none" w="med" len="med"/>
-                      <a:tailEnd type="none" w="med" len="med"/>
-                    </a:lnL>
-                    <a:lnR w="9525" cap="flat" cmpd="sng" algn="ctr">
-                      <a:solidFill>
-                        <a:srgbClr val="E4E9EF"/>
-                      </a:solidFill>
-                      <a:prstDash val="solid"/>
-                      <a:round/>
-                      <a:headEnd type="none" w="med" len="med"/>
-                      <a:tailEnd type="none" w="med" len="med"/>
-                    </a:lnR>
-                    <a:lnT w="9525" cap="flat" cmpd="sng" algn="ctr">
-                      <a:solidFill>
-                        <a:srgbClr val="E4E9EF"/>
-                      </a:solidFill>
-                      <a:prstDash val="solid"/>
-                      <a:round/>
-                      <a:headEnd type="none" w="med" len="med"/>
-                      <a:tailEnd type="none" w="med" len="med"/>
-                    </a:lnT>
-                    <a:lnB w="9525" cap="flat" cmpd="sng" algn="ctr">
-                      <a:solidFill>
-                        <a:srgbClr val="E4E9EF"/>
-                      </a:solidFill>
-                      <a:prstDash val="solid"/>
-                      <a:round/>
-                      <a:headEnd type="none" w="med" len="med"/>
-                      <a:tailEnd type="none" w="med" len="med"/>
-                    </a:lnB>
-                    <a:solidFill>
-                      <a:srgbClr val="FFFFFF"/>
-                    </a:solidFill>
-                  </a:tcPr>
-                </a:tc>
-                <a:tc>
-                  <a:txBody>
-                    <a:bodyPr/>
-                    <a:lstStyle/>
-                    <a:p>
-                      <a:pPr algn="ctr" indent="0" marL="0">
-                        <a:buNone/>
-                      </a:pPr>
-                      <a:r>
-                        <a:rPr lang="en-US" sz="1050" dirty="0">
-                          <a:solidFill>
-                            <a:srgbClr val="1C2B3A"/>
-                          </a:solidFill>
-                          <a:latin typeface="Calibri" pitchFamily="34" charset="0"/>
-                          <a:ea typeface="Calibri" pitchFamily="34" charset="-122"/>
-                          <a:cs typeface="Calibri" pitchFamily="34" charset="-120"/>
-                        </a:rPr>
-                        <a:t>41.2% (range 39-44)</a:t>
-                      </a:r>
-                      <a:endParaRPr lang="en-US" sz="1050" dirty="0">
-                        <a:latin typeface="Calibri" charset="0"/>
-                        <a:ea typeface="Calibri" charset="0"/>
-                        <a:cs typeface="Calibri" charset="0"/>
-                      </a:endParaRPr>
-                    </a:p>
-                  </a:txBody>
-                  <a:tcPr marL="91440" marR="91440" marT="45720" marB="45720" anchor="ctr">
-                    <a:lnL w="9525" cap="flat" cmpd="sng" algn="ctr">
-                      <a:solidFill>
-                        <a:srgbClr val="E4E9EF"/>
-                      </a:solidFill>
-                      <a:prstDash val="solid"/>
-                      <a:round/>
-                      <a:headEnd type="none" w="med" len="med"/>
-                      <a:tailEnd type="none" w="med" len="med"/>
-                    </a:lnL>
-                    <a:lnR w="9525" cap="flat" cmpd="sng" algn="ctr">
-                      <a:solidFill>
-                        <a:srgbClr val="E4E9EF"/>
-                      </a:solidFill>
-                      <a:prstDash val="solid"/>
-                      <a:round/>
-                      <a:headEnd type="none" w="med" len="med"/>
-                      <a:tailEnd type="none" w="med" len="med"/>
-                    </a:lnR>
-                    <a:lnT w="9525" cap="flat" cmpd="sng" algn="ctr">
-                      <a:solidFill>
-                        <a:srgbClr val="E4E9EF"/>
-                      </a:solidFill>
-                      <a:prstDash val="solid"/>
-                      <a:round/>
-                      <a:headEnd type="none" w="med" len="med"/>
-                      <a:tailEnd type="none" w="med" len="med"/>
-                    </a:lnT>
-                    <a:lnB w="9525" cap="flat" cmpd="sng" algn="ctr">
-                      <a:solidFill>
-                        <a:srgbClr val="E4E9EF"/>
-                      </a:solidFill>
-                      <a:prstDash val="solid"/>
-                      <a:round/>
-                      <a:headEnd type="none" w="med" len="med"/>
-                      <a:tailEnd type="none" w="med" len="med"/>
-                    </a:lnB>
-                    <a:solidFill>
-                      <a:srgbClr val="FFFFFF"/>
-                    </a:solidFill>
-                  </a:tcPr>
-                </a:tc>
-                <a:tc>
-                  <a:txBody>
-                    <a:bodyPr/>
-                    <a:lstStyle/>
-                    <a:p>
-                      <a:pPr algn="ctr" indent="0" marL="0">
-                        <a:buNone/>
-                      </a:pPr>
-                      <a:r>
-                        <a:rPr lang="en-US" sz="1050" b="1" dirty="0">
-                          <a:solidFill>
-                            <a:srgbClr val="1E7A46"/>
-                          </a:solidFill>
-                          <a:latin typeface="Calibri" pitchFamily="34" charset="0"/>
-                          <a:ea typeface="Calibri" pitchFamily="34" charset="-122"/>
-                          <a:cs typeface="Calibri" pitchFamily="34" charset="-120"/>
-                        </a:rPr>
-                        <a:t>close</a:t>
-                      </a:r>
-                      <a:endParaRPr lang="en-US" sz="1050" dirty="0">
-                        <a:latin typeface="Calibri" charset="0"/>
-                        <a:ea typeface="Calibri" charset="0"/>
-                        <a:cs typeface="Calibri" charset="0"/>
-                      </a:endParaRPr>
-                    </a:p>
-                  </a:txBody>
-                  <a:tcPr marL="91440" marR="91440" marT="45720" marB="45720" anchor="ctr">
-                    <a:lnL w="9525" cap="flat" cmpd="sng" algn="ctr">
-                      <a:solidFill>
-                        <a:srgbClr val="E4E9EF"/>
-                      </a:solidFill>
-                      <a:prstDash val="solid"/>
-                      <a:round/>
-                      <a:headEnd type="none" w="med" len="med"/>
-                      <a:tailEnd type="none" w="med" len="med"/>
-                    </a:lnL>
-                    <a:lnR w="9525" cap="flat" cmpd="sng" algn="ctr">
-                      <a:solidFill>
-                        <a:srgbClr val="E4E9EF"/>
-                      </a:solidFill>
-                      <a:prstDash val="solid"/>
-                      <a:round/>
-                      <a:headEnd type="none" w="med" len="med"/>
-                      <a:tailEnd type="none" w="med" len="med"/>
-                    </a:lnR>
-                    <a:lnT w="9525" cap="flat" cmpd="sng" algn="ctr">
-                      <a:solidFill>
-                        <a:srgbClr val="E4E9EF"/>
-                      </a:solidFill>
-                      <a:prstDash val="solid"/>
-                      <a:round/>
-                      <a:headEnd type="none" w="med" len="med"/>
-                      <a:tailEnd type="none" w="med" len="med"/>
-                    </a:lnT>
-                    <a:lnB w="9525" cap="flat" cmpd="sng" algn="ctr">
-                      <a:solidFill>
-                        <a:srgbClr val="E4E9EF"/>
-                      </a:solidFill>
-                      <a:prstDash val="solid"/>
-                      <a:round/>
-                      <a:headEnd type="none" w="med" len="med"/>
-                      <a:tailEnd type="none" w="med" len="med"/>
-                    </a:lnB>
-                    <a:solidFill>
-                      <a:srgbClr val="FFFFFF"/>
-                    </a:solidFill>
-                  </a:tcPr>
-                </a:tc>
-              </a:tr>
-              <a:tr h="310896">
-                <a:tc>
-                  <a:txBody>
-                    <a:bodyPr/>
-                    <a:lstStyle/>
-                    <a:p>
-                      <a:pPr indent="0" marL="0">
-                        <a:buNone/>
-                      </a:pPr>
-                      <a:r>
-                        <a:rPr lang="en-US" sz="1050" dirty="0">
-                          <a:solidFill>
-                            <a:srgbClr val="1C2B3A"/>
-                          </a:solidFill>
-                          <a:latin typeface="Calibri" pitchFamily="34" charset="0"/>
-                          <a:ea typeface="Calibri" pitchFamily="34" charset="-122"/>
-                          <a:cs typeface="Calibri" pitchFamily="34" charset="-120"/>
-                        </a:rPr>
-                        <a:t>Edgecombe corner-3 share → projection</a:t>
-                      </a:r>
-                      <a:endParaRPr lang="en-US" sz="1050" dirty="0">
-                        <a:latin typeface="Calibri" charset="0"/>
-                        <a:ea typeface="Calibri" charset="0"/>
-                        <a:cs typeface="Calibri" charset="0"/>
-                      </a:endParaRPr>
-                    </a:p>
-                  </a:txBody>
-                  <a:tcPr marL="91440" marR="91440" marT="45720" marB="45720" anchor="ctr">
-                    <a:lnL w="9525" cap="flat" cmpd="sng" algn="ctr">
-                      <a:solidFill>
-                        <a:srgbClr val="E4E9EF"/>
-                      </a:solidFill>
-                      <a:prstDash val="solid"/>
-                      <a:round/>
-                      <a:headEnd type="none" w="med" len="med"/>
-                      <a:tailEnd type="none" w="med" len="med"/>
-                    </a:lnL>
-                    <a:lnR w="9525" cap="flat" cmpd="sng" algn="ctr">
-                      <a:solidFill>
-                        <a:srgbClr val="E4E9EF"/>
-                      </a:solidFill>
-                      <a:prstDash val="solid"/>
-                      <a:round/>
-                      <a:headEnd type="none" w="med" len="med"/>
-                      <a:tailEnd type="none" w="med" len="med"/>
-                    </a:lnR>
-                    <a:lnT w="9525" cap="flat" cmpd="sng" algn="ctr">
-                      <a:solidFill>
-                        <a:srgbClr val="E4E9EF"/>
-                      </a:solidFill>
-                      <a:prstDash val="solid"/>
-                      <a:round/>
-                      <a:headEnd type="none" w="med" len="med"/>
-                      <a:tailEnd type="none" w="med" len="med"/>
-                    </a:lnT>
-                    <a:lnB w="9525" cap="flat" cmpd="sng" algn="ctr">
-                      <a:solidFill>
-                        <a:srgbClr val="E4E9EF"/>
-                      </a:solidFill>
-                      <a:prstDash val="solid"/>
-                      <a:round/>
-                      <a:headEnd type="none" w="med" len="med"/>
-                      <a:tailEnd type="none" w="med" len="med"/>
-                    </a:lnB>
-                    <a:solidFill>
-                      <a:srgbClr val="FFFFFF"/>
-                    </a:solidFill>
-                  </a:tcPr>
-                </a:tc>
-                <a:tc>
-                  <a:txBody>
-                    <a:bodyPr/>
-                    <a:lstStyle/>
-                    <a:p>
-                      <a:pPr algn="ctr" indent="0" marL="0">
-                        <a:buNone/>
-                      </a:pPr>
-                      <a:r>
-                        <a:rPr lang="en-US" sz="1050" dirty="0">
-                          <a:solidFill>
-                            <a:srgbClr val="1C2B3A"/>
-                          </a:solidFill>
-                          <a:latin typeface="Calibri" pitchFamily="34" charset="0"/>
-                          <a:ea typeface="Calibri" pitchFamily="34" charset="-122"/>
-                          <a:cs typeface="Calibri" pitchFamily="34" charset="-120"/>
-                        </a:rPr>
-                        <a:t>8% → 12%</a:t>
-                      </a:r>
-                      <a:endParaRPr lang="en-US" sz="1050" dirty="0">
-                        <a:latin typeface="Calibri" charset="0"/>
-                        <a:ea typeface="Calibri" charset="0"/>
-                        <a:cs typeface="Calibri" charset="0"/>
-                      </a:endParaRPr>
-                    </a:p>
-                  </a:txBody>
-                  <a:tcPr marL="91440" marR="91440" marT="45720" marB="45720" anchor="ctr">
-                    <a:lnL w="9525" cap="flat" cmpd="sng" algn="ctr">
-                      <a:solidFill>
-                        <a:srgbClr val="E4E9EF"/>
-                      </a:solidFill>
-                      <a:prstDash val="solid"/>
-                      <a:round/>
-                      <a:headEnd type="none" w="med" len="med"/>
-                      <a:tailEnd type="none" w="med" len="med"/>
-                    </a:lnL>
-                    <a:lnR w="9525" cap="flat" cmpd="sng" algn="ctr">
-                      <a:solidFill>
-                        <a:srgbClr val="E4E9EF"/>
-                      </a:solidFill>
-                      <a:prstDash val="solid"/>
-                      <a:round/>
-                      <a:headEnd type="none" w="med" len="med"/>
-                      <a:tailEnd type="none" w="med" len="med"/>
-                    </a:lnR>
-                    <a:lnT w="9525" cap="flat" cmpd="sng" algn="ctr">
-                      <a:solidFill>
-                        <a:srgbClr val="E4E9EF"/>
-                      </a:solidFill>
-                      <a:prstDash val="solid"/>
-                      <a:round/>
-                      <a:headEnd type="none" w="med" len="med"/>
-                      <a:tailEnd type="none" w="med" len="med"/>
-                    </a:lnT>
-                    <a:lnB w="9525" cap="flat" cmpd="sng" algn="ctr">
-                      <a:solidFill>
-                        <a:srgbClr val="E4E9EF"/>
-                      </a:solidFill>
-                      <a:prstDash val="solid"/>
-                      <a:round/>
-                      <a:headEnd type="none" w="med" len="med"/>
-                      <a:tailEnd type="none" w="med" len="med"/>
-                    </a:lnB>
-                    <a:solidFill>
-                      <a:srgbClr val="FFFFFF"/>
-                    </a:solidFill>
-                  </a:tcPr>
-                </a:tc>
-                <a:tc>
-                  <a:txBody>
-                    <a:bodyPr/>
-                    <a:lstStyle/>
-                    <a:p>
-                      <a:pPr algn="ctr" indent="0" marL="0">
-                        <a:buNone/>
-                      </a:pPr>
-                      <a:r>
-                        <a:rPr lang="en-US" sz="1050" dirty="0">
-                          <a:solidFill>
-                            <a:srgbClr val="1C2B3A"/>
-                          </a:solidFill>
-                          <a:latin typeface="Calibri" pitchFamily="34" charset="0"/>
-                          <a:ea typeface="Calibri" pitchFamily="34" charset="-122"/>
-                          <a:cs typeface="Calibri" pitchFamily="34" charset="-120"/>
-                        </a:rPr>
-                        <a:t>5.5% → 6.9%</a:t>
-                      </a:r>
-                      <a:endParaRPr lang="en-US" sz="1050" dirty="0">
-                        <a:latin typeface="Calibri" charset="0"/>
-                        <a:ea typeface="Calibri" charset="0"/>
-                        <a:cs typeface="Calibri" charset="0"/>
-                      </a:endParaRPr>
-                    </a:p>
-                  </a:txBody>
-                  <a:tcPr marL="91440" marR="91440" marT="45720" marB="45720" anchor="ctr">
-                    <a:lnL w="9525" cap="flat" cmpd="sng" algn="ctr">
-                      <a:solidFill>
-                        <a:srgbClr val="E4E9EF"/>
-                      </a:solidFill>
-                      <a:prstDash val="solid"/>
-                      <a:round/>
-                      <a:headEnd type="none" w="med" len="med"/>
-                      <a:tailEnd type="none" w="med" len="med"/>
-                    </a:lnL>
-                    <a:lnR w="9525" cap="flat" cmpd="sng" algn="ctr">
-                      <a:solidFill>
-                        <a:srgbClr val="E4E9EF"/>
-                      </a:solidFill>
-                      <a:prstDash val="solid"/>
-                      <a:round/>
-                      <a:headEnd type="none" w="med" len="med"/>
-                      <a:tailEnd type="none" w="med" len="med"/>
-                    </a:lnR>
-                    <a:lnT w="9525" cap="flat" cmpd="sng" algn="ctr">
-                      <a:solidFill>
-                        <a:srgbClr val="E4E9EF"/>
-                      </a:solidFill>
-                      <a:prstDash val="solid"/>
-                      <a:round/>
-                      <a:headEnd type="none" w="med" len="med"/>
-                      <a:tailEnd type="none" w="med" len="med"/>
-                    </a:lnT>
-                    <a:lnB w="9525" cap="flat" cmpd="sng" algn="ctr">
-                      <a:solidFill>
-                        <a:srgbClr val="E4E9EF"/>
-                      </a:solidFill>
-                      <a:prstDash val="solid"/>
-                      <a:round/>
-                      <a:headEnd type="none" w="med" len="med"/>
-                      <a:tailEnd type="none" w="med" len="med"/>
-                    </a:lnB>
-                    <a:solidFill>
-                      <a:srgbClr val="FFFFFF"/>
-                    </a:solidFill>
-                  </a:tcPr>
-                </a:tc>
-                <a:tc>
-                  <a:txBody>
-                    <a:bodyPr/>
-                    <a:lstStyle/>
-                    <a:p>
-                      <a:pPr algn="ctr" indent="0" marL="0">
-                        <a:buNone/>
-                      </a:pPr>
-                      <a:r>
-                        <a:rPr lang="en-US" sz="1050" b="1" dirty="0">
-                          <a:solidFill>
-                            <a:srgbClr val="C8102E"/>
-                          </a:solidFill>
-                          <a:latin typeface="Calibri" pitchFamily="34" charset="0"/>
-                          <a:ea typeface="Calibri" pitchFamily="34" charset="-122"/>
-                          <a:cs typeface="Calibri" pitchFamily="34" charset="-120"/>
-                        </a:rPr>
-                        <a:t>wrong</a:t>
-                      </a:r>
-                      <a:endParaRPr lang="en-US" sz="1050" dirty="0">
-                        <a:latin typeface="Calibri" charset="0"/>
-                        <a:ea typeface="Calibri" charset="0"/>
-                        <a:cs typeface="Calibri" charset="0"/>
-                      </a:endParaRPr>
-                    </a:p>
-                  </a:txBody>
-                  <a:tcPr marL="91440" marR="91440" marT="45720" marB="45720" anchor="ctr">
-                    <a:lnL w="9525" cap="flat" cmpd="sng" algn="ctr">
-                      <a:solidFill>
-                        <a:srgbClr val="E4E9EF"/>
-                      </a:solidFill>
-                      <a:prstDash val="solid"/>
-                      <a:round/>
-                      <a:headEnd type="none" w="med" len="med"/>
-                      <a:tailEnd type="none" w="med" len="med"/>
-                    </a:lnL>
-                    <a:lnR w="9525" cap="flat" cmpd="sng" algn="ctr">
-                      <a:solidFill>
-                        <a:srgbClr val="E4E9EF"/>
-                      </a:solidFill>
-                      <a:prstDash val="solid"/>
-                      <a:round/>
-                      <a:headEnd type="none" w="med" len="med"/>
-                      <a:tailEnd type="none" w="med" len="med"/>
-                    </a:lnR>
-                    <a:lnT w="9525" cap="flat" cmpd="sng" algn="ctr">
-                      <a:solidFill>
-                        <a:srgbClr val="E4E9EF"/>
-                      </a:solidFill>
-                      <a:prstDash val="solid"/>
-                      <a:round/>
-                      <a:headEnd type="none" w="med" len="med"/>
-                      <a:tailEnd type="none" w="med" len="med"/>
-                    </a:lnT>
-                    <a:lnB w="9525" cap="flat" cmpd="sng" algn="ctr">
-                      <a:solidFill>
-                        <a:srgbClr val="E4E9EF"/>
-                      </a:solidFill>
-                      <a:prstDash val="solid"/>
-                      <a:round/>
-                      <a:headEnd type="none" w="med" len="med"/>
-                      <a:tailEnd type="none" w="med" len="med"/>
-                    </a:lnB>
-                    <a:solidFill>
-                      <a:srgbClr val="FFFFFF"/>
-                    </a:solidFill>
-                  </a:tcPr>
-                </a:tc>
-              </a:tr>
-              <a:tr h="310896">
-                <a:tc>
-                  <a:txBody>
-                    <a:bodyPr/>
-                    <a:lstStyle/>
-                    <a:p>
-                      <a:pPr indent="0" marL="0">
-                        <a:buNone/>
-                      </a:pPr>
-                      <a:r>
-                        <a:rPr lang="en-US" sz="1050" dirty="0">
-                          <a:solidFill>
-                            <a:srgbClr val="1C2B3A"/>
-                          </a:solidFill>
-                          <a:latin typeface="Calibri" pitchFamily="34" charset="0"/>
-                          <a:ea typeface="Calibri" pitchFamily="34" charset="-122"/>
-                          <a:cs typeface="Calibri" pitchFamily="34" charset="-120"/>
-                        </a:rPr>
-                        <a:t>LeBron projected usage / TS</a:t>
-                      </a:r>
-                      <a:endParaRPr lang="en-US" sz="1050" dirty="0">
-                        <a:latin typeface="Calibri" charset="0"/>
-                        <a:ea typeface="Calibri" charset="0"/>
-                        <a:cs typeface="Calibri" charset="0"/>
-                      </a:endParaRPr>
-                    </a:p>
-                  </a:txBody>
-                  <a:tcPr marL="91440" marR="91440" marT="45720" marB="45720" anchor="ctr">
-                    <a:lnL w="9525" cap="flat" cmpd="sng" algn="ctr">
-                      <a:solidFill>
-                        <a:srgbClr val="E4E9EF"/>
-                      </a:solidFill>
-                      <a:prstDash val="solid"/>
-                      <a:round/>
-                      <a:headEnd type="none" w="med" len="med"/>
-                      <a:tailEnd type="none" w="med" len="med"/>
-                    </a:lnL>
-                    <a:lnR w="9525" cap="flat" cmpd="sng" algn="ctr">
-                      <a:solidFill>
-                        <a:srgbClr val="E4E9EF"/>
-                      </a:solidFill>
-                      <a:prstDash val="solid"/>
-                      <a:round/>
-                      <a:headEnd type="none" w="med" len="med"/>
-                      <a:tailEnd type="none" w="med" len="med"/>
-                    </a:lnR>
-                    <a:lnT w="9525" cap="flat" cmpd="sng" algn="ctr">
-                      <a:solidFill>
-                        <a:srgbClr val="E4E9EF"/>
-                      </a:solidFill>
-                      <a:prstDash val="solid"/>
-                      <a:round/>
-                      <a:headEnd type="none" w="med" len="med"/>
-                      <a:tailEnd type="none" w="med" len="med"/>
-                    </a:lnT>
-                    <a:lnB w="9525" cap="flat" cmpd="sng" algn="ctr">
-                      <a:solidFill>
-                        <a:srgbClr val="E4E9EF"/>
-                      </a:solidFill>
-                      <a:prstDash val="solid"/>
-                      <a:round/>
-                      <a:headEnd type="none" w="med" len="med"/>
-                      <a:tailEnd type="none" w="med" len="med"/>
-                    </a:lnB>
-                    <a:solidFill>
-                      <a:srgbClr val="FFFFFF"/>
-                    </a:solidFill>
-                  </a:tcPr>
-                </a:tc>
-                <a:tc>
-                  <a:txBody>
-                    <a:bodyPr/>
-                    <a:lstStyle/>
-                    <a:p>
-                      <a:pPr algn="ctr" indent="0" marL="0">
-                        <a:buNone/>
-                      </a:pPr>
-                      <a:r>
-                        <a:rPr lang="en-US" sz="1050" dirty="0">
-                          <a:solidFill>
-                            <a:srgbClr val="1C2B3A"/>
-                          </a:solidFill>
-                          <a:latin typeface="Calibri" pitchFamily="34" charset="0"/>
-                          <a:ea typeface="Calibri" pitchFamily="34" charset="-122"/>
-                          <a:cs typeface="Calibri" pitchFamily="34" charset="-120"/>
-                        </a:rPr>
-                        <a:t>22% / .627</a:t>
-                      </a:r>
-                      <a:endParaRPr lang="en-US" sz="1050" dirty="0">
-                        <a:latin typeface="Calibri" charset="0"/>
-                        <a:ea typeface="Calibri" charset="0"/>
-                        <a:cs typeface="Calibri" charset="0"/>
-                      </a:endParaRPr>
-                    </a:p>
-                  </a:txBody>
-                  <a:tcPr marL="91440" marR="91440" marT="45720" marB="45720" anchor="ctr">
-                    <a:lnL w="9525" cap="flat" cmpd="sng" algn="ctr">
-                      <a:solidFill>
-                        <a:srgbClr val="E4E9EF"/>
-                      </a:solidFill>
-                      <a:prstDash val="solid"/>
-                      <a:round/>
-                      <a:headEnd type="none" w="med" len="med"/>
-                      <a:tailEnd type="none" w="med" len="med"/>
-                    </a:lnL>
-                    <a:lnR w="9525" cap="flat" cmpd="sng" algn="ctr">
-                      <a:solidFill>
-                        <a:srgbClr val="E4E9EF"/>
-                      </a:solidFill>
-                      <a:prstDash val="solid"/>
-                      <a:round/>
-                      <a:headEnd type="none" w="med" len="med"/>
-                      <a:tailEnd type="none" w="med" len="med"/>
-                    </a:lnR>
-                    <a:lnT w="9525" cap="flat" cmpd="sng" algn="ctr">
-                      <a:solidFill>
-                        <a:srgbClr val="E4E9EF"/>
-                      </a:solidFill>
-                      <a:prstDash val="solid"/>
-                      <a:round/>
-                      <a:headEnd type="none" w="med" len="med"/>
-                      <a:tailEnd type="none" w="med" len="med"/>
-                    </a:lnT>
-                    <a:lnB w="9525" cap="flat" cmpd="sng" algn="ctr">
-                      <a:solidFill>
-                        <a:srgbClr val="E4E9EF"/>
-                      </a:solidFill>
-                      <a:prstDash val="solid"/>
-                      <a:round/>
-                      <a:headEnd type="none" w="med" len="med"/>
-                      <a:tailEnd type="none" w="med" len="med"/>
-                    </a:lnB>
-                    <a:solidFill>
-                      <a:srgbClr val="FFFFFF"/>
-                    </a:solidFill>
-                  </a:tcPr>
-                </a:tc>
-                <a:tc>
-                  <a:txBody>
-                    <a:bodyPr/>
-                    <a:lstStyle/>
-                    <a:p>
-                      <a:pPr algn="ctr" indent="0" marL="0">
-                        <a:buNone/>
-                      </a:pPr>
-                      <a:r>
-                        <a:rPr lang="en-US" sz="1050" dirty="0">
-                          <a:solidFill>
-                            <a:srgbClr val="1C2B3A"/>
-                          </a:solidFill>
-                          <a:latin typeface="Calibri" pitchFamily="34" charset="0"/>
-                          <a:ea typeface="Calibri" pitchFamily="34" charset="-122"/>
-                          <a:cs typeface="Calibri" pitchFamily="34" charset="-120"/>
-                        </a:rPr>
-                        <a:t>21.5% / .60-.63</a:t>
-                      </a:r>
-                      <a:endParaRPr lang="en-US" sz="1050" dirty="0">
-                        <a:latin typeface="Calibri" charset="0"/>
-                        <a:ea typeface="Calibri" charset="0"/>
-                        <a:cs typeface="Calibri" charset="0"/>
-                      </a:endParaRPr>
-                    </a:p>
-                  </a:txBody>
-                  <a:tcPr marL="91440" marR="91440" marT="45720" marB="45720" anchor="ctr">
-                    <a:lnL w="9525" cap="flat" cmpd="sng" algn="ctr">
-                      <a:solidFill>
-                        <a:srgbClr val="E4E9EF"/>
-                      </a:solidFill>
-                      <a:prstDash val="solid"/>
-                      <a:round/>
-                      <a:headEnd type="none" w="med" len="med"/>
-                      <a:tailEnd type="none" w="med" len="med"/>
-                    </a:lnL>
-                    <a:lnR w="9525" cap="flat" cmpd="sng" algn="ctr">
-                      <a:solidFill>
-                        <a:srgbClr val="E4E9EF"/>
-                      </a:solidFill>
-                      <a:prstDash val="solid"/>
-                      <a:round/>
-                      <a:headEnd type="none" w="med" len="med"/>
-                      <a:tailEnd type="none" w="med" len="med"/>
-                    </a:lnR>
-                    <a:lnT w="9525" cap="flat" cmpd="sng" algn="ctr">
-                      <a:solidFill>
-                        <a:srgbClr val="E4E9EF"/>
-                      </a:solidFill>
-                      <a:prstDash val="solid"/>
-                      <a:round/>
-                      <a:headEnd type="none" w="med" len="med"/>
-                      <a:tailEnd type="none" w="med" len="med"/>
-                    </a:lnT>
-                    <a:lnB w="9525" cap="flat" cmpd="sng" algn="ctr">
-                      <a:solidFill>
-                        <a:srgbClr val="E4E9EF"/>
-                      </a:solidFill>
-                      <a:prstDash val="solid"/>
-                      <a:round/>
-                      <a:headEnd type="none" w="med" len="med"/>
-                      <a:tailEnd type="none" w="med" len="med"/>
-                    </a:lnB>
-                    <a:solidFill>
-                      <a:srgbClr val="FFFFFF"/>
-                    </a:solidFill>
-                  </a:tcPr>
-                </a:tc>
-                <a:tc>
-                  <a:txBody>
-                    <a:bodyPr/>
-                    <a:lstStyle/>
-                    <a:p>
-                      <a:pPr algn="ctr" indent="0" marL="0">
-                        <a:buNone/>
-                      </a:pPr>
-                      <a:r>
-                        <a:rPr lang="en-US" sz="1050" b="1" dirty="0">
-                          <a:solidFill>
-                            <a:srgbClr val="B07A00"/>
-                          </a:solidFill>
-                          <a:latin typeface="Calibri" pitchFamily="34" charset="0"/>
-                          <a:ea typeface="Calibri" pitchFamily="34" charset="-122"/>
-                          <a:cs typeface="Calibri" pitchFamily="34" charset="-120"/>
-                        </a:rPr>
-                        <a:t>edge</a:t>
-                      </a:r>
-                      <a:endParaRPr lang="en-US" sz="1050" dirty="0">
-                        <a:latin typeface="Calibri" charset="0"/>
-                        <a:ea typeface="Calibri" charset="0"/>
-                        <a:cs typeface="Calibri" charset="0"/>
-                      </a:endParaRPr>
-                    </a:p>
-                  </a:txBody>
-                  <a:tcPr marL="91440" marR="91440" marT="45720" marB="45720" anchor="ctr">
-                    <a:lnL w="9525" cap="flat" cmpd="sng" algn="ctr">
-                      <a:solidFill>
-                        <a:srgbClr val="E4E9EF"/>
-                      </a:solidFill>
-                      <a:prstDash val="solid"/>
-                      <a:round/>
-                      <a:headEnd type="none" w="med" len="med"/>
-                      <a:tailEnd type="none" w="med" len="med"/>
-                    </a:lnL>
-                    <a:lnR w="9525" cap="flat" cmpd="sng" algn="ctr">
-                      <a:solidFill>
-                        <a:srgbClr val="E4E9EF"/>
-                      </a:solidFill>
-                      <a:prstDash val="solid"/>
-                      <a:round/>
-                      <a:headEnd type="none" w="med" len="med"/>
-                      <a:tailEnd type="none" w="med" len="med"/>
-                    </a:lnR>
-                    <a:lnT w="9525" cap="flat" cmpd="sng" algn="ctr">
-                      <a:solidFill>
-                        <a:srgbClr val="E4E9EF"/>
-                      </a:solidFill>
-                      <a:prstDash val="solid"/>
-                      <a:round/>
-                      <a:headEnd type="none" w="med" len="med"/>
-                      <a:tailEnd type="none" w="med" len="med"/>
-                    </a:lnT>
-                    <a:lnB w="9525" cap="flat" cmpd="sng" algn="ctr">
-                      <a:solidFill>
-                        <a:srgbClr val="E4E9EF"/>
-                      </a:solidFill>
-                      <a:prstDash val="solid"/>
-                      <a:round/>
-                      <a:headEnd type="none" w="med" len="med"/>
-                      <a:tailEnd type="none" w="med" len="med"/>
-                    </a:lnB>
-                    <a:solidFill>
-                      <a:srgbClr val="FFFFFF"/>
-                    </a:solidFill>
-                  </a:tcPr>
-                </a:tc>
-              </a:tr>
-              <a:tr h="310896">
-                <a:tc>
-                  <a:txBody>
-                    <a:bodyPr/>
-                    <a:lstStyle/>
-                    <a:p>
-                      <a:pPr indent="0" marL="0">
-                        <a:buNone/>
-                      </a:pPr>
-                      <a:r>
-                        <a:rPr lang="en-US" sz="1050" dirty="0">
-                          <a:solidFill>
-                            <a:srgbClr val="1C2B3A"/>
-                          </a:solidFill>
-                          <a:latin typeface="Calibri" pitchFamily="34" charset="0"/>
-                          <a:ea typeface="Calibri" pitchFamily="34" charset="-122"/>
-                          <a:cs typeface="Calibri" pitchFamily="34" charset="-120"/>
-                        </a:rPr>
-                        <a:t>Finals odds: 45w → 51w</a:t>
-                      </a:r>
-                      <a:endParaRPr lang="en-US" sz="1050" dirty="0">
-                        <a:latin typeface="Calibri" charset="0"/>
-                        <a:ea typeface="Calibri" charset="0"/>
-                        <a:cs typeface="Calibri" charset="0"/>
-                      </a:endParaRPr>
-                    </a:p>
-                  </a:txBody>
-                  <a:tcPr marL="91440" marR="91440" marT="45720" marB="45720" anchor="ctr">
-                    <a:lnL w="9525" cap="flat" cmpd="sng" algn="ctr">
-                      <a:solidFill>
-                        <a:srgbClr val="E4E9EF"/>
-                      </a:solidFill>
-                      <a:prstDash val="solid"/>
-                      <a:round/>
-                      <a:headEnd type="none" w="med" len="med"/>
-                      <a:tailEnd type="none" w="med" len="med"/>
-                    </a:lnL>
-                    <a:lnR w="9525" cap="flat" cmpd="sng" algn="ctr">
-                      <a:solidFill>
-                        <a:srgbClr val="E4E9EF"/>
-                      </a:solidFill>
-                      <a:prstDash val="solid"/>
-                      <a:round/>
-                      <a:headEnd type="none" w="med" len="med"/>
-                      <a:tailEnd type="none" w="med" len="med"/>
-                    </a:lnR>
-                    <a:lnT w="9525" cap="flat" cmpd="sng" algn="ctr">
-                      <a:solidFill>
-                        <a:srgbClr val="E4E9EF"/>
-                      </a:solidFill>
-                      <a:prstDash val="solid"/>
-                      <a:round/>
-                      <a:headEnd type="none" w="med" len="med"/>
-                      <a:tailEnd type="none" w="med" len="med"/>
-                    </a:lnT>
-                    <a:lnB w="9525" cap="flat" cmpd="sng" algn="ctr">
-                      <a:solidFill>
-                        <a:srgbClr val="E4E9EF"/>
-                      </a:solidFill>
-                      <a:prstDash val="solid"/>
-                      <a:round/>
-                      <a:headEnd type="none" w="med" len="med"/>
-                      <a:tailEnd type="none" w="med" len="med"/>
-                    </a:lnB>
-                    <a:solidFill>
-                      <a:srgbClr val="FFFFFF"/>
-                    </a:solidFill>
-                  </a:tcPr>
-                </a:tc>
-                <a:tc>
-                  <a:txBody>
-                    <a:bodyPr/>
-                    <a:lstStyle/>
-                    <a:p>
-                      <a:pPr algn="ctr" indent="0" marL="0">
-                        <a:buNone/>
-                      </a:pPr>
-                      <a:r>
-                        <a:rPr lang="en-US" sz="1050" dirty="0">
-                          <a:solidFill>
-                            <a:srgbClr val="1C2B3A"/>
-                          </a:solidFill>
-                          <a:latin typeface="Calibri" pitchFamily="34" charset="0"/>
-                          <a:ea typeface="Calibri" pitchFamily="34" charset="-122"/>
-                          <a:cs typeface="Calibri" pitchFamily="34" charset="-120"/>
-                        </a:rPr>
-                        <a:t>4% → 12% (3.2×)</a:t>
-                      </a:r>
-                      <a:endParaRPr lang="en-US" sz="1050" dirty="0">
-                        <a:latin typeface="Calibri" charset="0"/>
-                        <a:ea typeface="Calibri" charset="0"/>
-                        <a:cs typeface="Calibri" charset="0"/>
-                      </a:endParaRPr>
-                    </a:p>
-                  </a:txBody>
-                  <a:tcPr marL="91440" marR="91440" marT="45720" marB="45720" anchor="ctr">
-                    <a:lnL w="9525" cap="flat" cmpd="sng" algn="ctr">
-                      <a:solidFill>
-                        <a:srgbClr val="E4E9EF"/>
-                      </a:solidFill>
-                      <a:prstDash val="solid"/>
-                      <a:round/>
-                      <a:headEnd type="none" w="med" len="med"/>
-                      <a:tailEnd type="none" w="med" len="med"/>
-                    </a:lnL>
-                    <a:lnR w="9525" cap="flat" cmpd="sng" algn="ctr">
-                      <a:solidFill>
-                        <a:srgbClr val="E4E9EF"/>
-                      </a:solidFill>
-                      <a:prstDash val="solid"/>
-                      <a:round/>
-                      <a:headEnd type="none" w="med" len="med"/>
-                      <a:tailEnd type="none" w="med" len="med"/>
-                    </a:lnR>
-                    <a:lnT w="9525" cap="flat" cmpd="sng" algn="ctr">
-                      <a:solidFill>
-                        <a:srgbClr val="E4E9EF"/>
-                      </a:solidFill>
-                      <a:prstDash val="solid"/>
-                      <a:round/>
-                      <a:headEnd type="none" w="med" len="med"/>
-                      <a:tailEnd type="none" w="med" len="med"/>
-                    </a:lnT>
-                    <a:lnB w="9525" cap="flat" cmpd="sng" algn="ctr">
-                      <a:solidFill>
-                        <a:srgbClr val="E4E9EF"/>
-                      </a:solidFill>
-                      <a:prstDash val="solid"/>
-                      <a:round/>
-                      <a:headEnd type="none" w="med" len="med"/>
-                      <a:tailEnd type="none" w="med" len="med"/>
-                    </a:lnB>
-                    <a:solidFill>
-                      <a:srgbClr val="FFFFFF"/>
-                    </a:solidFill>
-                  </a:tcPr>
-                </a:tc>
-                <a:tc>
-                  <a:txBody>
-                    <a:bodyPr/>
-                    <a:lstStyle/>
-                    <a:p>
-                      <a:pPr algn="ctr" indent="0" marL="0">
-                        <a:buNone/>
-                      </a:pPr>
-                      <a:r>
-                        <a:rPr lang="en-US" sz="1050" dirty="0">
-                          <a:solidFill>
-                            <a:srgbClr val="1C2B3A"/>
-                          </a:solidFill>
-                          <a:latin typeface="Calibri" pitchFamily="34" charset="0"/>
-                          <a:ea typeface="Calibri" pitchFamily="34" charset="-122"/>
-                          <a:cs typeface="Calibri" pitchFamily="34" charset="-120"/>
-                        </a:rPr>
-                        <a:t>2.1% → 8.1% (3.8×); empirics 2.6%</a:t>
-                      </a:r>
-                      <a:endParaRPr lang="en-US" sz="1050" dirty="0">
-                        <a:latin typeface="Calibri" charset="0"/>
-                        <a:ea typeface="Calibri" charset="0"/>
-                        <a:cs typeface="Calibri" charset="0"/>
-                      </a:endParaRPr>
-                    </a:p>
-                  </a:txBody>
-                  <a:tcPr marL="91440" marR="91440" marT="45720" marB="45720" anchor="ctr">
-                    <a:lnL w="9525" cap="flat" cmpd="sng" algn="ctr">
-                      <a:solidFill>
-                        <a:srgbClr val="E4E9EF"/>
-                      </a:solidFill>
-                      <a:prstDash val="solid"/>
-                      <a:round/>
-                      <a:headEnd type="none" w="med" len="med"/>
-                      <a:tailEnd type="none" w="med" len="med"/>
-                    </a:lnL>
-                    <a:lnR w="9525" cap="flat" cmpd="sng" algn="ctr">
-                      <a:solidFill>
-                        <a:srgbClr val="E4E9EF"/>
-                      </a:solidFill>
-                      <a:prstDash val="solid"/>
-                      <a:round/>
-                      <a:headEnd type="none" w="med" len="med"/>
-                      <a:tailEnd type="none" w="med" len="med"/>
-                    </a:lnR>
-                    <a:lnT w="9525" cap="flat" cmpd="sng" algn="ctr">
-                      <a:solidFill>
-                        <a:srgbClr val="E4E9EF"/>
-                      </a:solidFill>
-                      <a:prstDash val="solid"/>
-                      <a:round/>
-                      <a:headEnd type="none" w="med" len="med"/>
-                      <a:tailEnd type="none" w="med" len="med"/>
-                    </a:lnT>
-                    <a:lnB w="9525" cap="flat" cmpd="sng" algn="ctr">
-                      <a:solidFill>
-                        <a:srgbClr val="E4E9EF"/>
-                      </a:solidFill>
-                      <a:prstDash val="solid"/>
-                      <a:round/>
-                      <a:headEnd type="none" w="med" len="med"/>
-                      <a:tailEnd type="none" w="med" len="med"/>
-                    </a:lnB>
-                    <a:solidFill>
-                      <a:srgbClr val="FFFFFF"/>
-                    </a:solidFill>
-                  </a:tcPr>
-                </a:tc>
-                <a:tc>
-                  <a:txBody>
-                    <a:bodyPr/>
-                    <a:lstStyle/>
-                    <a:p>
-                      <a:pPr algn="ctr" indent="0" marL="0">
-                        <a:buNone/>
-                      </a:pPr>
-                      <a:r>
-                        <a:rPr lang="en-US" sz="1050" b="1" dirty="0">
-                          <a:solidFill>
-                            <a:srgbClr val="B07A00"/>
-                          </a:solidFill>
-                          <a:latin typeface="Calibri" pitchFamily="34" charset="0"/>
-                          <a:ea typeface="Calibri" pitchFamily="34" charset="-122"/>
-                          <a:cs typeface="Calibri" pitchFamily="34" charset="-120"/>
-                        </a:rPr>
-                        <a:t>shape ✓</a:t>
-                      </a:r>
-                      <a:endParaRPr lang="en-US" sz="1050" dirty="0">
-                        <a:latin typeface="Calibri" charset="0"/>
-                        <a:ea typeface="Calibri" charset="0"/>
-                        <a:cs typeface="Calibri" charset="0"/>
-                      </a:endParaRPr>
-                    </a:p>
-                  </a:txBody>
-                  <a:tcPr marL="91440" marR="91440" marT="45720" marB="45720" anchor="ctr">
-                    <a:lnL w="9525" cap="flat" cmpd="sng" algn="ctr">
-                      <a:solidFill>
-                        <a:srgbClr val="E4E9EF"/>
-                      </a:solidFill>
-                      <a:prstDash val="solid"/>
-                      <a:round/>
-                      <a:headEnd type="none" w="med" len="med"/>
-                      <a:tailEnd type="none" w="med" len="med"/>
-                    </a:lnL>
-                    <a:lnR w="9525" cap="flat" cmpd="sng" algn="ctr">
-                      <a:solidFill>
-                        <a:srgbClr val="E4E9EF"/>
-                      </a:solidFill>
-                      <a:prstDash val="solid"/>
-                      <a:round/>
-                      <a:headEnd type="none" w="med" len="med"/>
-                      <a:tailEnd type="none" w="med" len="med"/>
-                    </a:lnR>
-                    <a:lnT w="9525" cap="flat" cmpd="sng" algn="ctr">
-                      <a:solidFill>
-                        <a:srgbClr val="E4E9EF"/>
-                      </a:solidFill>
-                      <a:prstDash val="solid"/>
-                      <a:round/>
-                      <a:headEnd type="none" w="med" len="med"/>
-                      <a:tailEnd type="none" w="med" len="med"/>
-                    </a:lnT>
-                    <a:lnB w="9525" cap="flat" cmpd="sng" algn="ctr">
-                      <a:solidFill>
-                        <a:srgbClr val="E4E9EF"/>
-                      </a:solidFill>
-                      <a:prstDash val="solid"/>
-                      <a:round/>
-                      <a:headEnd type="none" w="med" len="med"/>
-                      <a:tailEnd type="none" w="med" len="med"/>
-                    </a:lnB>
-                    <a:solidFill>
-                      <a:srgbClr val="FFFFFF"/>
-                    </a:solidFill>
-                  </a:tcPr>
-                </a:tc>
-              </a:tr>
-            </a:tbl>
-          </a:graphicData>
-        </a:graphic>
-      </p:graphicFrame>
-      <p:sp>
-        <p:nvSpPr>
-          <p:cNvPr id="5" name="Text 2"/>
-          <p:cNvSpPr/>
-          <p:nvPr/>
-        </p:nvSpPr>
-        <p:spPr>
-          <a:xfrm>
-            <a:off x="548640" y="6419088"/>
-            <a:ext cx="10634472" cy="292608"/>
-          </a:xfrm>
-          <a:prstGeom prst="rect">
-            <a:avLst/>
-          </a:prstGeom>
-          <a:noFill/>
-          <a:ln/>
-        </p:spPr>
-        <p:txBody>
-          <a:bodyPr wrap="square" lIns="0" tIns="0" rIns="0" bIns="0" rtlCol="0" anchor="ctr"/>
-          <a:lstStyle/>
-          <a:p>
-            <a:pPr algn="l" indent="0" marL="0">
-              <a:buNone/>
-            </a:pPr>
-            <a:r>
-              <a:rPr lang="en-US" sz="900" dirty="0">
-                <a:solidFill>
-                  <a:srgbClr val="5B6B7C"/>
-                </a:solidFill>
-                <a:latin typeface="Calibri" pitchFamily="34" charset="0"/>
-                <a:ea typeface="Calibri" pitchFamily="34" charset="-122"/>
-                <a:cs typeface="Calibri" pitchFamily="34" charset="-120"/>
-              </a:rPr>
-              <a:t>Verdicts: 'exact' = matches verified data to rounding; 'close' = within the modeled range; 'wrong' = not supported by play-by-play shot data.</a:t>
-            </a:r>
-            <a:endParaRPr lang="en-US" sz="900" dirty="0"/>
-          </a:p>
-        </p:txBody>
-      </p:sp>
-      <p:sp>
-        <p:nvSpPr>
-          <p:cNvPr id="6" name="Text 3"/>
-          <p:cNvSpPr/>
-          <p:nvPr/>
-        </p:nvSpPr>
-        <p:spPr>
-          <a:xfrm>
-            <a:off x="11274552" y="6419088"/>
-            <a:ext cx="365760" cy="292608"/>
-          </a:xfrm>
-          <a:prstGeom prst="rect">
-            <a:avLst/>
-          </a:prstGeom>
-          <a:noFill/>
-          <a:ln/>
-        </p:spPr>
-        <p:txBody>
-          <a:bodyPr wrap="square" lIns="0" tIns="0" rIns="0" bIns="0" rtlCol="0" anchor="ctr"/>
-          <a:lstStyle/>
-          <a:p>
-            <a:pPr algn="r" indent="0" marL="0">
-              <a:buNone/>
-            </a:pPr>
-            <a:r>
-              <a:rPr lang="en-US" sz="900" dirty="0">
-                <a:solidFill>
-                  <a:srgbClr val="5B6B7C"/>
-                </a:solidFill>
-                <a:latin typeface="Calibri" pitchFamily="34" charset="0"/>
-                <a:ea typeface="Calibri" pitchFamily="34" charset="-122"/>
-                <a:cs typeface="Calibri" pitchFamily="34" charset="-120"/>
-              </a:rPr>
-              <a:t>12</a:t>
-            </a:r>
-            <a:endParaRPr lang="en-US" sz="900" dirty="0"/>
-          </a:p>
-        </p:txBody>
-      </p:sp>
-    </p:spTree>
-  </p:cSld>
-  <p:clrMapOvr>
-    <a:masterClrMapping/>
-  </p:clrMapOvr>
-</p:sld>
-</file>
-
-<file path=ppt/slides/slide13.xml><?xml version="1.0" encoding="utf-8"?>
-<p:sld xmlns:a="http://schemas.openxmlformats.org/drawingml/2006/main" xmlns:r="http://schemas.openxmlformats.org/officeDocument/2006/relationships" xmlns:p="http://schemas.openxmlformats.org/presentationml/2006/main">
-  <p:cSld name="Slide 13">
     <p:bg>
       <p:bgPr>
         <a:solidFill>
@@ -10387,7 +6509,7 @@
                 <a:ea typeface="Calibri" pitchFamily="34" charset="-122"/>
                 <a:cs typeface="Calibri" pitchFamily="34" charset="-120"/>
               </a:rPr>
-              <a:t>Where the video’s inputs failed verification (Edgecombe 8%, ‘765 assists’), the verified numbers are used and flagged on the slide.
+              <a:t>Stat sites draw shot zones differently (corner-3, at-rim); pbpstats’ exact play-by-play counts are used, with alternates noted in slide footers.
 </a:t>
             </a:r>
             <a:pPr indent="0" marL="0">
@@ -10444,7 +6566,7 @@
                 <a:ea typeface="Calibri" pitchFamily="34" charset="-122"/>
                 <a:cs typeface="Calibri" pitchFamily="34" charset="-120"/>
               </a:rPr>
-              <a:t>Original video: TikTok @leah.cammarano · rebuilt July 25, 2026</a:t>
+              <a:t>Compiled July 25, 2026 — the day after the signing.</a:t>
             </a:r>
             <a:endParaRPr lang="en-US" sz="1050" dirty="0"/>
           </a:p>
@@ -12055,7 +8177,7 @@
                 <a:ea typeface="Calibri" pitchFamily="34" charset="-122"/>
                 <a:cs typeface="Calibri" pitchFamily="34" charset="-120"/>
               </a:rPr>
-              <a:t>FanDuel set the post-signing win total at 50.5. Title odds moved +2000 → +900 (DraftKings) within hours. The video projected 51 — same answer, three routes.</a:t>
+              <a:t>FanDuel set the post-signing win total at 50.5. Title odds moved +2000 → +900 (DraftKings) within hours. Two independent routes, one answer.</a:t>
             </a:r>
             <a:endParaRPr lang="en-US" sz="1200" dirty="0"/>
           </a:p>
@@ -12472,7 +8594,7 @@
                 <a:ea typeface="Calibri" pitchFamily="34" charset="-122"/>
                 <a:cs typeface="Calibri" pitchFamily="34" charset="-120"/>
               </a:rPr>
-              <a:t>My model: </a:t>
+              <a:t>The model: </a:t>
             </a:r>
             <a:pPr indent="0" marL="0">
               <a:lnSpc>
@@ -12489,7 +8611,7 @@
                 <a:ea typeface="Calibri" pitchFamily="34" charset="-122"/>
                 <a:cs typeface="Calibri" pitchFamily="34" charset="-120"/>
               </a:rPr>
-              <a:t>Log5 game odds + home court, exact best-of-7, three rounds vs a 48/53/57-win gauntlet. 45 wins → 2.1%; 51 → 8.1%; 52 → 9.7% (4.6×). The video said 4% → 12%, “3.2×” — same shape, softer baseline.
+              <a:t>Log5 game odds + home court, exact best-of-7, three rounds vs a 48/53/57-win playoff gauntlet. 45 wins → 2.1%; 51 → 8.1% (3.8×); 52 → 9.7% (4.6×).
 </a:t>
             </a:r>
             <a:pPr indent="0" marL="0">
@@ -12507,7 +8629,7 @@
                 <a:ea typeface="Calibri" pitchFamily="34" charset="-122"/>
                 <a:cs typeface="Calibri" pitchFamily="34" charset="-120"/>
               </a:rPr>
-              <a:t>History is harsher: </a:t>
+              <a:t>History says the same: </a:t>
             </a:r>
             <a:pPr indent="0" marL="0">
               <a:lnSpc>
@@ -12542,7 +8664,7 @@
                 <a:ea typeface="Calibri" pitchFamily="34" charset="-122"/>
                 <a:cs typeface="Calibri" pitchFamily="34" charset="-120"/>
               </a:rPr>
-              <a:t>Same conclusion, stronger: </a:t>
+              <a:t>The point: </a:t>
             </a:r>
             <a:pPr indent="0" marL="0">
               <a:lnSpc>
@@ -12872,7 +8994,7 @@
                 <a:ea typeface="Calibri" pitchFamily="34" charset="-122"/>
                 <a:cs typeface="Calibri" pitchFamily="34" charset="-120"/>
               </a:rPr>
-              <a:t>guards who joined LeBron saw their assisted share rise +8.4 pts on average (Mo Williams +12.6, D’Angelo Russell +11.1, Kyrie +1.5 — and Kyrie’s 3P assisted share jumped 45.5→61.8%). Applied to Maxey: unassisted falls to ~47% (video said 45%).
+              <a:t>guards who joined LeBron saw their assisted share rise +8.4 pts on average (Mo Williams +12.6, D’Angelo Russell +11.1, Kyrie +1.5 — and Kyrie’s 3P assisted share jumped 45.5→61.8%). Applied to Maxey: unassisted falls to ~47%.
 </a:t>
             </a:r>
             <a:pPr indent="0" marL="0">
@@ -13203,7 +9325,7 @@
                 <a:ea typeface="Calibri" pitchFamily="34" charset="-122"/>
                 <a:cs typeface="Calibri" pitchFamily="34" charset="-120"/>
               </a:rPr>
-              <a:t>restore the healthy-co-star baseline, then add half the average LeBron-arrival premium (+4.0): ~52% assisted (video said 48%). LeBron delivers the ball early in the clock, not with three seconds left.
+              <a:t>restore the healthy-co-star baseline, then add half the average LeBron-arrival premium (+4.0): ~52% assisted. LeBron delivers the ball early in the clock, not with three seconds left.
 </a:t>
             </a:r>
             <a:pPr indent="0" marL="0">
@@ -13260,7 +9382,7 @@
                 <a:ea typeface="Calibri" pitchFamily="34" charset="-122"/>
                 <a:cs typeface="Calibri" pitchFamily="34" charset="-120"/>
               </a:rPr>
-              <a:t>Splits: pbpstats/B-Ref both seasons (25-26: 2P 32.4% astd, 3P 53.6%; 23-24: 42.9%/63.4%). Video’s ‘46%’ for 2023-24 is actually 47.6%.</a:t>
+              <a:t>Splits: pbpstats/B-Ref both seasons (25-26: 2P 32.4% astd, 3P 53.6% astd; 23-24: 42.9%/63.4%).</a:t>
             </a:r>
             <a:endParaRPr lang="en-US" sz="900" dirty="0"/>
           </a:p>
@@ -13552,7 +9674,7 @@
                 <a:ea typeface="Calibri" pitchFamily="34" charset="-122"/>
                 <a:cs typeface="Calibri" pitchFamily="34" charset="-120"/>
               </a:rPr>
-              <a:t>The video said 37% → 42% off “52% of 765 assists” — the right idea with the wrong inputs: it’s 34.9%, and 42.1% of 432.</a:t>
+              <a:t>Bosh and Love both saw double-digit jumps in assisted makes the year LeBron arrived. Embiid is a better interior finisher than either.</a:t>
             </a:r>
             <a:endParaRPr lang="en-US" sz="1250" dirty="0"/>
           </a:p>
@@ -13877,13 +9999,13 @@
             <a:r>
               <a:rPr lang="en-US" sz="1250" i="1" dirty="0">
                 <a:solidFill>
-                  <a:srgbClr val="C8102E"/>
+                  <a:srgbClr val="1C2B3A"/>
                 </a:solidFill>
                 <a:latin typeface="Calibri" pitchFamily="34" charset="0"/>
                 <a:ea typeface="Calibri" pitchFamily="34" charset="-122"/>
                 <a:cs typeface="Calibri" pitchFamily="34" charset="-120"/>
               </a:rPr>
-              <a:t>Honest note: the video’s 8% → 12% doesn’t match the shot data (5.5% baseline, 25 makes). The free points are real; the magnitude is smaller.</a:t>
+              <a:t>A ~30% relative jump in the most efficient catch-and-shoot look in basketball — free points that were just sitting there.</a:t>
             </a:r>
             <a:endParaRPr lang="en-US" sz="1250" dirty="0"/>
           </a:p>
@@ -13922,7 +10044,7 @@
                 <a:ea typeface="Calibri" pitchFamily="34" charset="-122"/>
                 <a:cs typeface="Calibri" pitchFamily="34" charset="-120"/>
               </a:rPr>
-              <a:t>Corner-3 counts: pbpstats (25 makes / 67 att). B-Ref’s different corner definition gives ~20 — either way, well under the video’s 8%.</a:t>
+              <a:t>Corner-3 counts: pbpstats (25 makes / 67 attempts). B-Ref’s different corner-zone definition gives ~20 makes.</a:t>
             </a:r>
             <a:endParaRPr lang="en-US" sz="900" dirty="0"/>
           </a:p>

</xml_diff>